<commit_message>
Added CEDA service interactions for #17'
</commit_message>
<xml_diff>
--- a/docs/CitationServiceDiagrams.pptx
+++ b/docs/CitationServiceDiagrams.pptx
@@ -7,6 +7,7 @@
   <p:sldIdLst>
     <p:sldId id="256" r:id="rId2"/>
     <p:sldId id="257" r:id="rId3"/>
+    <p:sldId id="258" r:id="rId4"/>
   </p:sldIdLst>
   <p:sldSz cx="12192000" cy="6858000"/>
   <p:notesSz cx="6858000" cy="9144000"/>
@@ -105,6 +106,11 @@
       </a:defRPr>
     </a:lvl9pPr>
   </p:defaultTextStyle>
+  <p:extLst>
+    <p:ext uri="{EFAFB233-063F-42B5-8137-9DF3F51BA10A}">
+      <p15:sldGuideLst xmlns:p15="http://schemas.microsoft.com/office/powerpoint/2012/main"/>
+    </p:ext>
+  </p:extLst>
 </p:presentation>
 </file>
 
@@ -4116,6 +4122,968 @@
     <p:extLst>
       <p:ext uri="{BB962C8B-B14F-4D97-AF65-F5344CB8AC3E}">
         <p14:creationId xmlns:p14="http://schemas.microsoft.com/office/powerpoint/2010/main" val="2485295759"/>
+      </p:ext>
+    </p:extLst>
+  </p:cSld>
+  <p:clrMapOvr>
+    <a:masterClrMapping/>
+  </p:clrMapOvr>
+</p:sld>
+</file>
+
+<file path=ppt/slides/slide3.xml><?xml version="1.0" encoding="utf-8"?>
+<p:sld xmlns:a="http://schemas.openxmlformats.org/drawingml/2006/main" xmlns:r="http://schemas.openxmlformats.org/officeDocument/2006/relationships" xmlns:p="http://schemas.openxmlformats.org/presentationml/2006/main">
+  <p:cSld>
+    <p:spTree>
+      <p:nvGrpSpPr>
+        <p:cNvPr id="1" name=""/>
+        <p:cNvGrpSpPr/>
+        <p:nvPr/>
+      </p:nvGrpSpPr>
+      <p:grpSpPr>
+        <a:xfrm>
+          <a:off x="0" y="0"/>
+          <a:ext cx="0" cy="0"/>
+          <a:chOff x="0" y="0"/>
+          <a:chExt cx="0" cy="0"/>
+        </a:xfrm>
+      </p:grpSpPr>
+      <p:sp>
+        <p:nvSpPr>
+          <p:cNvPr id="2" name="Title 1">
+            <a:extLst>
+              <a:ext uri="{FF2B5EF4-FFF2-40B4-BE49-F238E27FC236}">
+                <a16:creationId xmlns:a16="http://schemas.microsoft.com/office/drawing/2014/main" id="{0B0FF5CB-574D-F7DA-37E7-A150C61EC2DD}"/>
+              </a:ext>
+            </a:extLst>
+          </p:cNvPr>
+          <p:cNvSpPr>
+            <a:spLocks noGrp="1"/>
+          </p:cNvSpPr>
+          <p:nvPr>
+            <p:ph type="title"/>
+          </p:nvPr>
+        </p:nvSpPr>
+        <p:spPr/>
+        <p:txBody>
+          <a:bodyPr/>
+          <a:lstStyle/>
+          <a:p>
+            <a:r>
+              <a:rPr lang="en-GB" dirty="0"/>
+              <a:t>Interactions - East (CEDA)</a:t>
+            </a:r>
+          </a:p>
+        </p:txBody>
+      </p:sp>
+      <p:sp>
+        <p:nvSpPr>
+          <p:cNvPr id="4" name="Rectangle 3">
+            <a:extLst>
+              <a:ext uri="{FF2B5EF4-FFF2-40B4-BE49-F238E27FC236}">
+                <a16:creationId xmlns:a16="http://schemas.microsoft.com/office/drawing/2014/main" id="{072BBB06-8B0F-702E-89D7-550DFAA22825}"/>
+              </a:ext>
+            </a:extLst>
+          </p:cNvPr>
+          <p:cNvSpPr/>
+          <p:nvPr/>
+        </p:nvSpPr>
+        <p:spPr>
+          <a:xfrm>
+            <a:off x="3897488" y="2138802"/>
+            <a:ext cx="4397024" cy="2102379"/>
+          </a:xfrm>
+          <a:prstGeom prst="rect">
+            <a:avLst/>
+          </a:prstGeom>
+          <a:noFill/>
+          <a:ln>
+            <a:solidFill>
+              <a:srgbClr val="00B0F0"/>
+            </a:solidFill>
+            <a:prstDash val="dash"/>
+          </a:ln>
+        </p:spPr>
+        <p:style>
+          <a:lnRef idx="2">
+            <a:schemeClr val="accent1">
+              <a:shade val="15000"/>
+            </a:schemeClr>
+          </a:lnRef>
+          <a:fillRef idx="1">
+            <a:schemeClr val="accent1"/>
+          </a:fillRef>
+          <a:effectRef idx="0">
+            <a:schemeClr val="accent1"/>
+          </a:effectRef>
+          <a:fontRef idx="minor">
+            <a:schemeClr val="lt1"/>
+          </a:fontRef>
+        </p:style>
+        <p:txBody>
+          <a:bodyPr rtlCol="0" anchor="ctr"/>
+          <a:lstStyle/>
+          <a:p>
+            <a:pPr algn="ctr"/>
+            <a:r>
+              <a:rPr lang="en-GB" dirty="0">
+                <a:solidFill>
+                  <a:sysClr val="windowText" lastClr="000000"/>
+                </a:solidFill>
+              </a:rPr>
+              <a:t>Citation Service Deployment (k8s)</a:t>
+            </a:r>
+          </a:p>
+          <a:p>
+            <a:pPr algn="ctr"/>
+            <a:endParaRPr lang="en-GB" dirty="0">
+              <a:solidFill>
+                <a:sysClr val="windowText" lastClr="000000"/>
+              </a:solidFill>
+            </a:endParaRPr>
+          </a:p>
+          <a:p>
+            <a:pPr algn="ctr"/>
+            <a:endParaRPr lang="en-GB" dirty="0">
+              <a:solidFill>
+                <a:sysClr val="windowText" lastClr="000000"/>
+              </a:solidFill>
+            </a:endParaRPr>
+          </a:p>
+          <a:p>
+            <a:pPr algn="ctr"/>
+            <a:endParaRPr lang="en-GB" dirty="0">
+              <a:solidFill>
+                <a:sysClr val="windowText" lastClr="000000"/>
+              </a:solidFill>
+            </a:endParaRPr>
+          </a:p>
+          <a:p>
+            <a:pPr algn="ctr"/>
+            <a:endParaRPr lang="en-GB" dirty="0">
+              <a:solidFill>
+                <a:sysClr val="windowText" lastClr="000000"/>
+              </a:solidFill>
+            </a:endParaRPr>
+          </a:p>
+          <a:p>
+            <a:pPr algn="ctr"/>
+            <a:endParaRPr lang="en-GB" dirty="0">
+              <a:solidFill>
+                <a:sysClr val="windowText" lastClr="000000"/>
+              </a:solidFill>
+            </a:endParaRPr>
+          </a:p>
+          <a:p>
+            <a:pPr algn="ctr"/>
+            <a:endParaRPr lang="en-GB" dirty="0">
+              <a:solidFill>
+                <a:sysClr val="windowText" lastClr="000000"/>
+              </a:solidFill>
+            </a:endParaRPr>
+          </a:p>
+        </p:txBody>
+      </p:sp>
+      <p:sp>
+        <p:nvSpPr>
+          <p:cNvPr id="6" name="Rounded Rectangle 5">
+            <a:extLst>
+              <a:ext uri="{FF2B5EF4-FFF2-40B4-BE49-F238E27FC236}">
+                <a16:creationId xmlns:a16="http://schemas.microsoft.com/office/drawing/2014/main" id="{BD4FA21C-A05F-4577-4B68-F8B43B772381}"/>
+              </a:ext>
+            </a:extLst>
+          </p:cNvPr>
+          <p:cNvSpPr/>
+          <p:nvPr/>
+        </p:nvSpPr>
+        <p:spPr>
+          <a:xfrm>
+            <a:off x="4165600" y="2698925"/>
+            <a:ext cx="3860799" cy="394231"/>
+          </a:xfrm>
+          <a:prstGeom prst="roundRect">
+            <a:avLst/>
+          </a:prstGeom>
+          <a:noFill/>
+          <a:ln>
+            <a:solidFill>
+              <a:srgbClr val="00B0F0"/>
+            </a:solidFill>
+          </a:ln>
+        </p:spPr>
+        <p:style>
+          <a:lnRef idx="2">
+            <a:schemeClr val="accent1">
+              <a:shade val="15000"/>
+            </a:schemeClr>
+          </a:lnRef>
+          <a:fillRef idx="1">
+            <a:schemeClr val="accent1"/>
+          </a:fillRef>
+          <a:effectRef idx="0">
+            <a:schemeClr val="accent1"/>
+          </a:effectRef>
+          <a:fontRef idx="minor">
+            <a:schemeClr val="lt1"/>
+          </a:fontRef>
+        </p:style>
+        <p:txBody>
+          <a:bodyPr rtlCol="0" anchor="ctr"/>
+          <a:lstStyle/>
+          <a:p>
+            <a:pPr algn="ctr"/>
+            <a:r>
+              <a:rPr lang="en-GB" dirty="0">
+                <a:solidFill>
+                  <a:sysClr val="windowText" lastClr="000000"/>
+                </a:solidFill>
+              </a:rPr>
+              <a:t>Citation Service Container</a:t>
+            </a:r>
+          </a:p>
+        </p:txBody>
+      </p:sp>
+      <p:sp>
+        <p:nvSpPr>
+          <p:cNvPr id="7" name="Rounded Rectangle 6">
+            <a:extLst>
+              <a:ext uri="{FF2B5EF4-FFF2-40B4-BE49-F238E27FC236}">
+                <a16:creationId xmlns:a16="http://schemas.microsoft.com/office/drawing/2014/main" id="{1A8FE9BA-68AF-EBF6-4922-DE2222AB8642}"/>
+              </a:ext>
+            </a:extLst>
+          </p:cNvPr>
+          <p:cNvSpPr/>
+          <p:nvPr/>
+        </p:nvSpPr>
+        <p:spPr>
+          <a:xfrm>
+            <a:off x="4165599" y="3653279"/>
+            <a:ext cx="3860799" cy="394231"/>
+          </a:xfrm>
+          <a:prstGeom prst="roundRect">
+            <a:avLst/>
+          </a:prstGeom>
+          <a:noFill/>
+          <a:ln>
+            <a:solidFill>
+              <a:srgbClr val="00B0F0"/>
+            </a:solidFill>
+          </a:ln>
+        </p:spPr>
+        <p:style>
+          <a:lnRef idx="2">
+            <a:schemeClr val="accent1">
+              <a:shade val="15000"/>
+            </a:schemeClr>
+          </a:lnRef>
+          <a:fillRef idx="1">
+            <a:schemeClr val="accent1"/>
+          </a:fillRef>
+          <a:effectRef idx="0">
+            <a:schemeClr val="accent1"/>
+          </a:effectRef>
+          <a:fontRef idx="minor">
+            <a:schemeClr val="lt1"/>
+          </a:fontRef>
+        </p:style>
+        <p:txBody>
+          <a:bodyPr rtlCol="0" anchor="ctr"/>
+          <a:lstStyle/>
+          <a:p>
+            <a:pPr algn="ctr"/>
+            <a:r>
+              <a:rPr lang="en-GB" dirty="0">
+                <a:solidFill>
+                  <a:sysClr val="windowText" lastClr="000000"/>
+                </a:solidFill>
+              </a:rPr>
+              <a:t>Event Stream Listener</a:t>
+            </a:r>
+          </a:p>
+        </p:txBody>
+      </p:sp>
+      <p:cxnSp>
+        <p:nvCxnSpPr>
+          <p:cNvPr id="11" name="Straight Arrow Connector 10">
+            <a:extLst>
+              <a:ext uri="{FF2B5EF4-FFF2-40B4-BE49-F238E27FC236}">
+                <a16:creationId xmlns:a16="http://schemas.microsoft.com/office/drawing/2014/main" id="{AC9BAD49-B8A3-A82E-2033-48C2495CBD71}"/>
+              </a:ext>
+            </a:extLst>
+          </p:cNvPr>
+          <p:cNvCxnSpPr>
+            <a:cxnSpLocks/>
+          </p:cNvCxnSpPr>
+          <p:nvPr/>
+        </p:nvCxnSpPr>
+        <p:spPr>
+          <a:xfrm flipV="1">
+            <a:off x="6101642" y="3163934"/>
+            <a:ext cx="0" cy="445688"/>
+          </a:xfrm>
+          <a:prstGeom prst="straightConnector1">
+            <a:avLst/>
+          </a:prstGeom>
+          <a:ln>
+            <a:solidFill>
+              <a:srgbClr val="00B0F0"/>
+            </a:solidFill>
+            <a:tailEnd type="triangle"/>
+          </a:ln>
+        </p:spPr>
+        <p:style>
+          <a:lnRef idx="2">
+            <a:schemeClr val="accent1"/>
+          </a:lnRef>
+          <a:fillRef idx="0">
+            <a:schemeClr val="accent1"/>
+          </a:fillRef>
+          <a:effectRef idx="1">
+            <a:schemeClr val="accent1"/>
+          </a:effectRef>
+          <a:fontRef idx="minor">
+            <a:schemeClr val="tx1"/>
+          </a:fontRef>
+        </p:style>
+      </p:cxnSp>
+      <p:cxnSp>
+        <p:nvCxnSpPr>
+          <p:cNvPr id="13" name="Straight Arrow Connector 12">
+            <a:extLst>
+              <a:ext uri="{FF2B5EF4-FFF2-40B4-BE49-F238E27FC236}">
+                <a16:creationId xmlns:a16="http://schemas.microsoft.com/office/drawing/2014/main" id="{685962A1-863D-B4E5-7892-0D361E3C86B5}"/>
+              </a:ext>
+            </a:extLst>
+          </p:cNvPr>
+          <p:cNvCxnSpPr>
+            <a:cxnSpLocks/>
+          </p:cNvCxnSpPr>
+          <p:nvPr/>
+        </p:nvCxnSpPr>
+        <p:spPr>
+          <a:xfrm flipV="1">
+            <a:off x="6095998" y="4377490"/>
+            <a:ext cx="0" cy="1684643"/>
+          </a:xfrm>
+          <a:prstGeom prst="straightConnector1">
+            <a:avLst/>
+          </a:prstGeom>
+          <a:ln>
+            <a:solidFill>
+              <a:srgbClr val="00B0F0"/>
+            </a:solidFill>
+            <a:tailEnd type="triangle"/>
+          </a:ln>
+        </p:spPr>
+        <p:style>
+          <a:lnRef idx="2">
+            <a:schemeClr val="accent1"/>
+          </a:lnRef>
+          <a:fillRef idx="0">
+            <a:schemeClr val="accent1"/>
+          </a:fillRef>
+          <a:effectRef idx="1">
+            <a:schemeClr val="accent1"/>
+          </a:effectRef>
+          <a:fontRef idx="minor">
+            <a:schemeClr val="tx1"/>
+          </a:fontRef>
+        </p:style>
+      </p:cxnSp>
+      <p:sp>
+        <p:nvSpPr>
+          <p:cNvPr id="15" name="TextBox 14">
+            <a:extLst>
+              <a:ext uri="{FF2B5EF4-FFF2-40B4-BE49-F238E27FC236}">
+                <a16:creationId xmlns:a16="http://schemas.microsoft.com/office/drawing/2014/main" id="{5247A156-BDA1-749F-45C3-C359D1678DEB}"/>
+              </a:ext>
+            </a:extLst>
+          </p:cNvPr>
+          <p:cNvSpPr txBox="1"/>
+          <p:nvPr/>
+        </p:nvSpPr>
+        <p:spPr>
+          <a:xfrm>
+            <a:off x="6237382" y="4607633"/>
+            <a:ext cx="3578031" cy="646331"/>
+          </a:xfrm>
+          <a:prstGeom prst="rect">
+            <a:avLst/>
+          </a:prstGeom>
+          <a:noFill/>
+        </p:spPr>
+        <p:txBody>
+          <a:bodyPr wrap="none" rtlCol="0">
+            <a:spAutoFit/>
+          </a:bodyPr>
+          <a:lstStyle/>
+          <a:p>
+            <a:r>
+              <a:rPr lang="en-GB" dirty="0"/>
+              <a:t>ESGF Publisher (CEDA)</a:t>
+            </a:r>
+          </a:p>
+          <a:p>
+            <a:r>
+              <a:rPr lang="en-GB" dirty="0"/>
+              <a:t>- Sends messages to event stream</a:t>
+            </a:r>
+          </a:p>
+        </p:txBody>
+      </p:sp>
+      <p:cxnSp>
+        <p:nvCxnSpPr>
+          <p:cNvPr id="18" name="Straight Arrow Connector 17">
+            <a:extLst>
+              <a:ext uri="{FF2B5EF4-FFF2-40B4-BE49-F238E27FC236}">
+                <a16:creationId xmlns:a16="http://schemas.microsoft.com/office/drawing/2014/main" id="{2159104A-49C5-D336-39D4-B3FA392BAADC}"/>
+              </a:ext>
+            </a:extLst>
+          </p:cNvPr>
+          <p:cNvCxnSpPr>
+            <a:cxnSpLocks/>
+          </p:cNvCxnSpPr>
+          <p:nvPr/>
+        </p:nvCxnSpPr>
+        <p:spPr>
+          <a:xfrm flipH="1">
+            <a:off x="8026397" y="1805734"/>
+            <a:ext cx="745067" cy="827615"/>
+          </a:xfrm>
+          <a:prstGeom prst="straightConnector1">
+            <a:avLst/>
+          </a:prstGeom>
+          <a:ln>
+            <a:solidFill>
+              <a:srgbClr val="00B0F0"/>
+            </a:solidFill>
+            <a:tailEnd type="triangle"/>
+          </a:ln>
+        </p:spPr>
+        <p:style>
+          <a:lnRef idx="2">
+            <a:schemeClr val="accent1"/>
+          </a:lnRef>
+          <a:fillRef idx="0">
+            <a:schemeClr val="accent1"/>
+          </a:fillRef>
+          <a:effectRef idx="1">
+            <a:schemeClr val="accent1"/>
+          </a:effectRef>
+          <a:fontRef idx="minor">
+            <a:schemeClr val="tx1"/>
+          </a:fontRef>
+        </p:style>
+      </p:cxnSp>
+      <p:sp>
+        <p:nvSpPr>
+          <p:cNvPr id="21" name="TextBox 20">
+            <a:extLst>
+              <a:ext uri="{FF2B5EF4-FFF2-40B4-BE49-F238E27FC236}">
+                <a16:creationId xmlns:a16="http://schemas.microsoft.com/office/drawing/2014/main" id="{BA8B1692-9539-9338-4FC7-D951E6565517}"/>
+              </a:ext>
+            </a:extLst>
+          </p:cNvPr>
+          <p:cNvSpPr txBox="1"/>
+          <p:nvPr/>
+        </p:nvSpPr>
+        <p:spPr>
+          <a:xfrm>
+            <a:off x="8771464" y="1000324"/>
+            <a:ext cx="1531573" cy="1200329"/>
+          </a:xfrm>
+          <a:prstGeom prst="rect">
+            <a:avLst/>
+          </a:prstGeom>
+          <a:noFill/>
+        </p:spPr>
+        <p:txBody>
+          <a:bodyPr wrap="none" rtlCol="0">
+            <a:spAutoFit/>
+          </a:bodyPr>
+          <a:lstStyle/>
+          <a:p>
+            <a:pPr marL="285750" indent="-285750">
+              <a:buFont typeface="Arial" panose="020B0604020202020204" pitchFamily="34" charset="0"/>
+              <a:buChar char="•"/>
+            </a:pPr>
+            <a:r>
+              <a:rPr lang="en-GB" dirty="0"/>
+              <a:t>CVs Repo</a:t>
+            </a:r>
+          </a:p>
+          <a:p>
+            <a:pPr marL="285750" indent="-285750">
+              <a:buFont typeface="Arial" panose="020B0604020202020204" pitchFamily="34" charset="0"/>
+              <a:buChar char="•"/>
+            </a:pPr>
+            <a:r>
+              <a:rPr lang="en-GB" dirty="0"/>
+              <a:t>EMD Repo</a:t>
+            </a:r>
+          </a:p>
+          <a:p>
+            <a:pPr marL="285750" indent="-285750">
+              <a:buFont typeface="Arial" panose="020B0604020202020204" pitchFamily="34" charset="0"/>
+              <a:buChar char="•"/>
+            </a:pPr>
+            <a:r>
+              <a:rPr lang="en-GB" dirty="0"/>
+              <a:t>ORCID API</a:t>
+            </a:r>
+          </a:p>
+          <a:p>
+            <a:pPr marL="285750" indent="-285750">
+              <a:buFont typeface="Arial" panose="020B0604020202020204" pitchFamily="34" charset="0"/>
+              <a:buChar char="•"/>
+            </a:pPr>
+            <a:r>
+              <a:rPr lang="en-GB" dirty="0"/>
+              <a:t>ROR API</a:t>
+            </a:r>
+          </a:p>
+        </p:txBody>
+      </p:sp>
+      <p:cxnSp>
+        <p:nvCxnSpPr>
+          <p:cNvPr id="26" name="Straight Arrow Connector 25">
+            <a:extLst>
+              <a:ext uri="{FF2B5EF4-FFF2-40B4-BE49-F238E27FC236}">
+                <a16:creationId xmlns:a16="http://schemas.microsoft.com/office/drawing/2014/main" id="{0A071364-104A-5A1F-460B-15A00DE8688B}"/>
+              </a:ext>
+            </a:extLst>
+          </p:cNvPr>
+          <p:cNvCxnSpPr>
+            <a:cxnSpLocks/>
+          </p:cNvCxnSpPr>
+          <p:nvPr/>
+        </p:nvCxnSpPr>
+        <p:spPr>
+          <a:xfrm>
+            <a:off x="2942165" y="2138802"/>
+            <a:ext cx="1117600" cy="494547"/>
+          </a:xfrm>
+          <a:prstGeom prst="straightConnector1">
+            <a:avLst/>
+          </a:prstGeom>
+          <a:ln>
+            <a:solidFill>
+              <a:srgbClr val="00B0F0"/>
+            </a:solidFill>
+            <a:tailEnd type="triangle"/>
+          </a:ln>
+        </p:spPr>
+        <p:style>
+          <a:lnRef idx="2">
+            <a:schemeClr val="accent1"/>
+          </a:lnRef>
+          <a:fillRef idx="0">
+            <a:schemeClr val="accent1"/>
+          </a:fillRef>
+          <a:effectRef idx="1">
+            <a:schemeClr val="accent1"/>
+          </a:effectRef>
+          <a:fontRef idx="minor">
+            <a:schemeClr val="tx1"/>
+          </a:fontRef>
+        </p:style>
+      </p:cxnSp>
+      <p:sp>
+        <p:nvSpPr>
+          <p:cNvPr id="29" name="TextBox 28">
+            <a:extLst>
+              <a:ext uri="{FF2B5EF4-FFF2-40B4-BE49-F238E27FC236}">
+                <a16:creationId xmlns:a16="http://schemas.microsoft.com/office/drawing/2014/main" id="{B4C0F969-FFAB-6C0E-660E-9B832251BF77}"/>
+              </a:ext>
+            </a:extLst>
+          </p:cNvPr>
+          <p:cNvSpPr txBox="1"/>
+          <p:nvPr/>
+        </p:nvSpPr>
+        <p:spPr>
+          <a:xfrm>
+            <a:off x="1888964" y="1467556"/>
+            <a:ext cx="1531573" cy="646331"/>
+          </a:xfrm>
+          <a:prstGeom prst="rect">
+            <a:avLst/>
+          </a:prstGeom>
+          <a:noFill/>
+        </p:spPr>
+        <p:txBody>
+          <a:bodyPr wrap="square" rtlCol="0">
+            <a:spAutoFit/>
+          </a:bodyPr>
+          <a:lstStyle/>
+          <a:p>
+            <a:r>
+              <a:rPr lang="en-GB" dirty="0"/>
+              <a:t>API POSTs (West Node)</a:t>
+            </a:r>
+          </a:p>
+        </p:txBody>
+      </p:sp>
+      <p:cxnSp>
+        <p:nvCxnSpPr>
+          <p:cNvPr id="30" name="Straight Arrow Connector 29">
+            <a:extLst>
+              <a:ext uri="{FF2B5EF4-FFF2-40B4-BE49-F238E27FC236}">
+                <a16:creationId xmlns:a16="http://schemas.microsoft.com/office/drawing/2014/main" id="{B14C0388-BEA6-5D37-A14E-66C94640086D}"/>
+              </a:ext>
+            </a:extLst>
+          </p:cNvPr>
+          <p:cNvCxnSpPr>
+            <a:cxnSpLocks/>
+          </p:cNvCxnSpPr>
+          <p:nvPr/>
+        </p:nvCxnSpPr>
+        <p:spPr>
+          <a:xfrm>
+            <a:off x="8179058" y="3066879"/>
+            <a:ext cx="705298" cy="0"/>
+          </a:xfrm>
+          <a:prstGeom prst="straightConnector1">
+            <a:avLst/>
+          </a:prstGeom>
+          <a:ln>
+            <a:solidFill>
+              <a:srgbClr val="00B0F0"/>
+            </a:solidFill>
+            <a:tailEnd type="triangle"/>
+          </a:ln>
+        </p:spPr>
+        <p:style>
+          <a:lnRef idx="2">
+            <a:schemeClr val="accent1"/>
+          </a:lnRef>
+          <a:fillRef idx="0">
+            <a:schemeClr val="accent1"/>
+          </a:fillRef>
+          <a:effectRef idx="1">
+            <a:schemeClr val="accent1"/>
+          </a:effectRef>
+          <a:fontRef idx="minor">
+            <a:schemeClr val="tx1"/>
+          </a:fontRef>
+        </p:style>
+      </p:cxnSp>
+      <p:cxnSp>
+        <p:nvCxnSpPr>
+          <p:cNvPr id="33" name="Straight Arrow Connector 32">
+            <a:extLst>
+              <a:ext uri="{FF2B5EF4-FFF2-40B4-BE49-F238E27FC236}">
+                <a16:creationId xmlns:a16="http://schemas.microsoft.com/office/drawing/2014/main" id="{17DA81A4-9F55-BFC3-0178-E878F1E68C62}"/>
+              </a:ext>
+            </a:extLst>
+          </p:cNvPr>
+          <p:cNvCxnSpPr>
+            <a:cxnSpLocks/>
+          </p:cNvCxnSpPr>
+          <p:nvPr/>
+        </p:nvCxnSpPr>
+        <p:spPr>
+          <a:xfrm flipV="1">
+            <a:off x="8160455" y="1997161"/>
+            <a:ext cx="611009" cy="696628"/>
+          </a:xfrm>
+          <a:prstGeom prst="straightConnector1">
+            <a:avLst/>
+          </a:prstGeom>
+          <a:ln>
+            <a:solidFill>
+              <a:srgbClr val="00B0F0"/>
+            </a:solidFill>
+            <a:tailEnd type="triangle"/>
+          </a:ln>
+        </p:spPr>
+        <p:style>
+          <a:lnRef idx="2">
+            <a:schemeClr val="accent1"/>
+          </a:lnRef>
+          <a:fillRef idx="0">
+            <a:schemeClr val="accent1"/>
+          </a:fillRef>
+          <a:effectRef idx="1">
+            <a:schemeClr val="accent1"/>
+          </a:effectRef>
+          <a:fontRef idx="minor">
+            <a:schemeClr val="tx1"/>
+          </a:fontRef>
+        </p:style>
+      </p:cxnSp>
+      <p:cxnSp>
+        <p:nvCxnSpPr>
+          <p:cNvPr id="37" name="Straight Arrow Connector 36">
+            <a:extLst>
+              <a:ext uri="{FF2B5EF4-FFF2-40B4-BE49-F238E27FC236}">
+                <a16:creationId xmlns:a16="http://schemas.microsoft.com/office/drawing/2014/main" id="{F5C8D5C8-C263-C3F7-F23F-3662D078EB3E}"/>
+              </a:ext>
+            </a:extLst>
+          </p:cNvPr>
+          <p:cNvCxnSpPr>
+            <a:cxnSpLocks/>
+          </p:cNvCxnSpPr>
+          <p:nvPr/>
+        </p:nvCxnSpPr>
+        <p:spPr>
+          <a:xfrm flipH="1">
+            <a:off x="8160455" y="2896040"/>
+            <a:ext cx="723901" cy="0"/>
+          </a:xfrm>
+          <a:prstGeom prst="straightConnector1">
+            <a:avLst/>
+          </a:prstGeom>
+          <a:ln>
+            <a:solidFill>
+              <a:srgbClr val="00B0F0"/>
+            </a:solidFill>
+            <a:tailEnd type="triangle"/>
+          </a:ln>
+        </p:spPr>
+        <p:style>
+          <a:lnRef idx="2">
+            <a:schemeClr val="accent1"/>
+          </a:lnRef>
+          <a:fillRef idx="0">
+            <a:schemeClr val="accent1"/>
+          </a:fillRef>
+          <a:effectRef idx="1">
+            <a:schemeClr val="accent1"/>
+          </a:effectRef>
+          <a:fontRef idx="minor">
+            <a:schemeClr val="tx1"/>
+          </a:fontRef>
+        </p:style>
+      </p:cxnSp>
+      <p:sp>
+        <p:nvSpPr>
+          <p:cNvPr id="41" name="TextBox 40">
+            <a:extLst>
+              <a:ext uri="{FF2B5EF4-FFF2-40B4-BE49-F238E27FC236}">
+                <a16:creationId xmlns:a16="http://schemas.microsoft.com/office/drawing/2014/main" id="{ED443036-AAF1-D13F-06C6-69943E76B9E2}"/>
+              </a:ext>
+            </a:extLst>
+          </p:cNvPr>
+          <p:cNvSpPr txBox="1"/>
+          <p:nvPr/>
+        </p:nvSpPr>
+        <p:spPr>
+          <a:xfrm>
+            <a:off x="9018412" y="2794602"/>
+            <a:ext cx="1752852" cy="369332"/>
+          </a:xfrm>
+          <a:prstGeom prst="rect">
+            <a:avLst/>
+          </a:prstGeom>
+          <a:noFill/>
+        </p:spPr>
+        <p:txBody>
+          <a:bodyPr wrap="none" rtlCol="0">
+            <a:spAutoFit/>
+          </a:bodyPr>
+          <a:lstStyle/>
+          <a:p>
+            <a:r>
+              <a:rPr lang="en-GB" dirty="0" err="1"/>
+              <a:t>DataCite</a:t>
+            </a:r>
+            <a:r>
+              <a:rPr lang="en-GB" dirty="0"/>
+              <a:t> (DOIs)</a:t>
+            </a:r>
+          </a:p>
+        </p:txBody>
+      </p:sp>
+      <p:sp>
+        <p:nvSpPr>
+          <p:cNvPr id="42" name="Can 41">
+            <a:extLst>
+              <a:ext uri="{FF2B5EF4-FFF2-40B4-BE49-F238E27FC236}">
+                <a16:creationId xmlns:a16="http://schemas.microsoft.com/office/drawing/2014/main" id="{C4FE4150-B29B-8AA0-A352-F93210749FDA}"/>
+              </a:ext>
+            </a:extLst>
+          </p:cNvPr>
+          <p:cNvSpPr/>
+          <p:nvPr/>
+        </p:nvSpPr>
+        <p:spPr>
+          <a:xfrm>
+            <a:off x="1085141" y="2529862"/>
+            <a:ext cx="2116667" cy="686456"/>
+          </a:xfrm>
+          <a:prstGeom prst="can">
+            <a:avLst/>
+          </a:prstGeom>
+          <a:noFill/>
+          <a:ln>
+            <a:solidFill>
+              <a:srgbClr val="00B0F0"/>
+            </a:solidFill>
+          </a:ln>
+        </p:spPr>
+        <p:style>
+          <a:lnRef idx="2">
+            <a:schemeClr val="accent1">
+              <a:shade val="15000"/>
+            </a:schemeClr>
+          </a:lnRef>
+          <a:fillRef idx="1">
+            <a:schemeClr val="accent1"/>
+          </a:fillRef>
+          <a:effectRef idx="0">
+            <a:schemeClr val="accent1"/>
+          </a:effectRef>
+          <a:fontRef idx="minor">
+            <a:schemeClr val="lt1"/>
+          </a:fontRef>
+        </p:style>
+        <p:txBody>
+          <a:bodyPr rtlCol="0" anchor="ctr"/>
+          <a:lstStyle/>
+          <a:p>
+            <a:pPr algn="ctr"/>
+            <a:r>
+              <a:rPr lang="en-GB" dirty="0">
+                <a:solidFill>
+                  <a:sysClr val="windowText" lastClr="000000"/>
+                </a:solidFill>
+              </a:rPr>
+              <a:t>Primary Database</a:t>
+            </a:r>
+          </a:p>
+        </p:txBody>
+      </p:sp>
+      <p:cxnSp>
+        <p:nvCxnSpPr>
+          <p:cNvPr id="43" name="Straight Arrow Connector 42">
+            <a:extLst>
+              <a:ext uri="{FF2B5EF4-FFF2-40B4-BE49-F238E27FC236}">
+                <a16:creationId xmlns:a16="http://schemas.microsoft.com/office/drawing/2014/main" id="{2AA502AF-F592-3621-2C93-9C076A1AC721}"/>
+              </a:ext>
+            </a:extLst>
+          </p:cNvPr>
+          <p:cNvCxnSpPr>
+            <a:cxnSpLocks/>
+          </p:cNvCxnSpPr>
+          <p:nvPr/>
+        </p:nvCxnSpPr>
+        <p:spPr>
+          <a:xfrm>
+            <a:off x="3354467" y="2979268"/>
+            <a:ext cx="705298" cy="0"/>
+          </a:xfrm>
+          <a:prstGeom prst="straightConnector1">
+            <a:avLst/>
+          </a:prstGeom>
+          <a:ln>
+            <a:solidFill>
+              <a:srgbClr val="00B0F0"/>
+            </a:solidFill>
+            <a:tailEnd type="triangle"/>
+          </a:ln>
+        </p:spPr>
+        <p:style>
+          <a:lnRef idx="2">
+            <a:schemeClr val="accent1"/>
+          </a:lnRef>
+          <a:fillRef idx="0">
+            <a:schemeClr val="accent1"/>
+          </a:fillRef>
+          <a:effectRef idx="1">
+            <a:schemeClr val="accent1"/>
+          </a:effectRef>
+          <a:fontRef idx="minor">
+            <a:schemeClr val="tx1"/>
+          </a:fontRef>
+        </p:style>
+      </p:cxnSp>
+      <p:cxnSp>
+        <p:nvCxnSpPr>
+          <p:cNvPr id="44" name="Straight Arrow Connector 43">
+            <a:extLst>
+              <a:ext uri="{FF2B5EF4-FFF2-40B4-BE49-F238E27FC236}">
+                <a16:creationId xmlns:a16="http://schemas.microsoft.com/office/drawing/2014/main" id="{810CECD1-61CA-2E45-3AF0-FF304273DCBE}"/>
+              </a:ext>
+            </a:extLst>
+          </p:cNvPr>
+          <p:cNvCxnSpPr>
+            <a:cxnSpLocks/>
+          </p:cNvCxnSpPr>
+          <p:nvPr/>
+        </p:nvCxnSpPr>
+        <p:spPr>
+          <a:xfrm flipH="1">
+            <a:off x="3335864" y="2808429"/>
+            <a:ext cx="723901" cy="0"/>
+          </a:xfrm>
+          <a:prstGeom prst="straightConnector1">
+            <a:avLst/>
+          </a:prstGeom>
+          <a:ln>
+            <a:solidFill>
+              <a:srgbClr val="00B0F0"/>
+            </a:solidFill>
+            <a:tailEnd type="triangle"/>
+          </a:ln>
+        </p:spPr>
+        <p:style>
+          <a:lnRef idx="2">
+            <a:schemeClr val="accent1"/>
+          </a:lnRef>
+          <a:fillRef idx="0">
+            <a:schemeClr val="accent1"/>
+          </a:fillRef>
+          <a:effectRef idx="1">
+            <a:schemeClr val="accent1"/>
+          </a:effectRef>
+          <a:fontRef idx="minor">
+            <a:schemeClr val="tx1"/>
+          </a:fontRef>
+        </p:style>
+      </p:cxnSp>
+      <p:sp>
+        <p:nvSpPr>
+          <p:cNvPr id="45" name="TextBox 44">
+            <a:extLst>
+              <a:ext uri="{FF2B5EF4-FFF2-40B4-BE49-F238E27FC236}">
+                <a16:creationId xmlns:a16="http://schemas.microsoft.com/office/drawing/2014/main" id="{A8AE3B04-F9F3-6D47-9373-7FE5CDB4C97A}"/>
+              </a:ext>
+            </a:extLst>
+          </p:cNvPr>
+          <p:cNvSpPr txBox="1"/>
+          <p:nvPr/>
+        </p:nvSpPr>
+        <p:spPr>
+          <a:xfrm>
+            <a:off x="613830" y="3318517"/>
+            <a:ext cx="3059288" cy="646331"/>
+          </a:xfrm>
+          <a:prstGeom prst="rect">
+            <a:avLst/>
+          </a:prstGeom>
+          <a:noFill/>
+        </p:spPr>
+        <p:txBody>
+          <a:bodyPr wrap="square" rtlCol="0">
+            <a:spAutoFit/>
+          </a:bodyPr>
+          <a:lstStyle/>
+          <a:p>
+            <a:pPr marL="285750" indent="-285750">
+              <a:buFont typeface="Arial" panose="020B0604020202020204" pitchFamily="34" charset="0"/>
+              <a:buChar char="•"/>
+            </a:pPr>
+            <a:r>
+              <a:rPr lang="en-GB" dirty="0"/>
+              <a:t>Database hosted at CEDA or externally in the cloud?</a:t>
+            </a:r>
+          </a:p>
+        </p:txBody>
+      </p:sp>
+    </p:spTree>
+    <p:extLst>
+      <p:ext uri="{BB962C8B-B14F-4D97-AF65-F5344CB8AC3E}">
+        <p14:creationId xmlns:p14="http://schemas.microsoft.com/office/powerpoint/2010/main" val="3575568463"/>
       </p:ext>
     </p:extLst>
   </p:cSld>

</xml_diff>

<commit_message>
Updated diagrams, added publication_year to message requirements
</commit_message>
<xml_diff>
--- a/docs/CitationServiceDiagrams.pptx
+++ b/docs/CitationServiceDiagrams.pptx
@@ -8,8 +8,6 @@
     <p:sldId id="256" r:id="rId2"/>
     <p:sldId id="257" r:id="rId3"/>
     <p:sldId id="258" r:id="rId4"/>
-    <p:sldId id="259" r:id="rId5"/>
-    <p:sldId id="260" r:id="rId6"/>
   </p:sldIdLst>
   <p:sldSz cx="12192000" cy="6858000"/>
   <p:notesSz cx="6858000" cy="9144000"/>
@@ -263,7 +261,7 @@
           <a:p>
             <a:fld id="{F1103FFF-8F9B-6141-9094-6197B5FE636F}" type="datetimeFigureOut">
               <a:rPr lang="en-GB" smtClean="0"/>
-              <a:t>26/02/2026</a:t>
+              <a:t>17/04/2026</a:t>
             </a:fld>
             <a:endParaRPr lang="en-GB"/>
           </a:p>
@@ -461,7 +459,7 @@
           <a:p>
             <a:fld id="{F1103FFF-8F9B-6141-9094-6197B5FE636F}" type="datetimeFigureOut">
               <a:rPr lang="en-GB" smtClean="0"/>
-              <a:t>26/02/2026</a:t>
+              <a:t>17/04/2026</a:t>
             </a:fld>
             <a:endParaRPr lang="en-GB"/>
           </a:p>
@@ -669,7 +667,7 @@
           <a:p>
             <a:fld id="{F1103FFF-8F9B-6141-9094-6197B5FE636F}" type="datetimeFigureOut">
               <a:rPr lang="en-GB" smtClean="0"/>
-              <a:t>26/02/2026</a:t>
+              <a:t>17/04/2026</a:t>
             </a:fld>
             <a:endParaRPr lang="en-GB"/>
           </a:p>
@@ -867,7 +865,7 @@
           <a:p>
             <a:fld id="{F1103FFF-8F9B-6141-9094-6197B5FE636F}" type="datetimeFigureOut">
               <a:rPr lang="en-GB" smtClean="0"/>
-              <a:t>26/02/2026</a:t>
+              <a:t>17/04/2026</a:t>
             </a:fld>
             <a:endParaRPr lang="en-GB"/>
           </a:p>
@@ -1142,7 +1140,7 @@
           <a:p>
             <a:fld id="{F1103FFF-8F9B-6141-9094-6197B5FE636F}" type="datetimeFigureOut">
               <a:rPr lang="en-GB" smtClean="0"/>
-              <a:t>26/02/2026</a:t>
+              <a:t>17/04/2026</a:t>
             </a:fld>
             <a:endParaRPr lang="en-GB"/>
           </a:p>
@@ -1407,7 +1405,7 @@
           <a:p>
             <a:fld id="{F1103FFF-8F9B-6141-9094-6197B5FE636F}" type="datetimeFigureOut">
               <a:rPr lang="en-GB" smtClean="0"/>
-              <a:t>26/02/2026</a:t>
+              <a:t>17/04/2026</a:t>
             </a:fld>
             <a:endParaRPr lang="en-GB"/>
           </a:p>
@@ -1819,7 +1817,7 @@
           <a:p>
             <a:fld id="{F1103FFF-8F9B-6141-9094-6197B5FE636F}" type="datetimeFigureOut">
               <a:rPr lang="en-GB" smtClean="0"/>
-              <a:t>26/02/2026</a:t>
+              <a:t>17/04/2026</a:t>
             </a:fld>
             <a:endParaRPr lang="en-GB"/>
           </a:p>
@@ -1960,7 +1958,7 @@
           <a:p>
             <a:fld id="{F1103FFF-8F9B-6141-9094-6197B5FE636F}" type="datetimeFigureOut">
               <a:rPr lang="en-GB" smtClean="0"/>
-              <a:t>26/02/2026</a:t>
+              <a:t>17/04/2026</a:t>
             </a:fld>
             <a:endParaRPr lang="en-GB"/>
           </a:p>
@@ -2073,7 +2071,7 @@
           <a:p>
             <a:fld id="{F1103FFF-8F9B-6141-9094-6197B5FE636F}" type="datetimeFigureOut">
               <a:rPr lang="en-GB" smtClean="0"/>
-              <a:t>26/02/2026</a:t>
+              <a:t>17/04/2026</a:t>
             </a:fld>
             <a:endParaRPr lang="en-GB"/>
           </a:p>
@@ -2384,7 +2382,7 @@
           <a:p>
             <a:fld id="{F1103FFF-8F9B-6141-9094-6197B5FE636F}" type="datetimeFigureOut">
               <a:rPr lang="en-GB" smtClean="0"/>
-              <a:t>26/02/2026</a:t>
+              <a:t>17/04/2026</a:t>
             </a:fld>
             <a:endParaRPr lang="en-GB"/>
           </a:p>
@@ -2672,7 +2670,7 @@
           <a:p>
             <a:fld id="{F1103FFF-8F9B-6141-9094-6197B5FE636F}" type="datetimeFigureOut">
               <a:rPr lang="en-GB" smtClean="0"/>
-              <a:t>26/02/2026</a:t>
+              <a:t>17/04/2026</a:t>
             </a:fld>
             <a:endParaRPr lang="en-GB"/>
           </a:p>
@@ -2913,7 +2911,7 @@
           <a:p>
             <a:fld id="{F1103FFF-8F9B-6141-9094-6197B5FE636F}" type="datetimeFigureOut">
               <a:rPr lang="en-GB" smtClean="0"/>
-              <a:t>26/02/2026</a:t>
+              <a:t>17/04/2026</a:t>
             </a:fld>
             <a:endParaRPr lang="en-GB"/>
           </a:p>
@@ -3429,7 +3427,12 @@
             <p:ph type="title"/>
           </p:nvPr>
         </p:nvSpPr>
-        <p:spPr/>
+        <p:spPr>
+          <a:xfrm>
+            <a:off x="606782" y="130527"/>
+            <a:ext cx="5741122" cy="1325563"/>
+          </a:xfrm>
+        </p:spPr>
         <p:txBody>
           <a:bodyPr/>
           <a:lstStyle/>
@@ -3455,7 +3458,7 @@
         </p:nvSpPr>
         <p:spPr>
           <a:xfrm>
-            <a:off x="5686779" y="1690689"/>
+            <a:off x="5689601" y="2028724"/>
             <a:ext cx="914400" cy="914400"/>
           </a:xfrm>
           <a:prstGeom prst="rect">
@@ -3635,76 +3638,17 @@
                   <a:sysClr val="windowText" lastClr="000000"/>
                 </a:solidFill>
               </a:rPr>
-              <a:t>Primary DB (API Write only)</a:t>
-            </a:r>
-          </a:p>
-        </p:txBody>
-      </p:sp>
-      <p:sp>
-        <p:nvSpPr>
-          <p:cNvPr id="7" name="Can 6">
-            <a:extLst>
-              <a:ext uri="{FF2B5EF4-FFF2-40B4-BE49-F238E27FC236}">
-                <a16:creationId xmlns:a16="http://schemas.microsoft.com/office/drawing/2014/main" id="{99E3BBE0-1296-7765-DEBF-0DBB99AB633F}"/>
-              </a:ext>
-            </a:extLst>
-          </p:cNvPr>
-          <p:cNvSpPr/>
-          <p:nvPr/>
-        </p:nvSpPr>
-        <p:spPr>
-          <a:xfrm>
-            <a:off x="838200" y="4366633"/>
-            <a:ext cx="2116667" cy="769811"/>
-          </a:xfrm>
-          <a:prstGeom prst="can">
-            <a:avLst/>
-          </a:prstGeom>
-          <a:noFill/>
-          <a:ln>
-            <a:solidFill>
-              <a:srgbClr val="00B0F0"/>
-            </a:solidFill>
-          </a:ln>
-        </p:spPr>
-        <p:style>
-          <a:lnRef idx="2">
-            <a:schemeClr val="accent1">
-              <a:shade val="15000"/>
-            </a:schemeClr>
-          </a:lnRef>
-          <a:fillRef idx="1">
-            <a:schemeClr val="accent1"/>
-          </a:fillRef>
-          <a:effectRef idx="0">
-            <a:schemeClr val="accent1"/>
-          </a:effectRef>
-          <a:fontRef idx="minor">
-            <a:schemeClr val="lt1"/>
-          </a:fontRef>
-        </p:style>
-        <p:txBody>
-          <a:bodyPr rtlCol="0" anchor="ctr"/>
-          <a:lstStyle/>
-          <a:p>
-            <a:pPr algn="ctr"/>
-            <a:r>
-              <a:rPr lang="en-GB" dirty="0">
-                <a:solidFill>
-                  <a:sysClr val="windowText" lastClr="000000"/>
-                </a:solidFill>
-              </a:rPr>
-              <a:t>Primary DB (API Write only)</a:t>
+              <a:t>East Node DB</a:t>
             </a:r>
           </a:p>
         </p:txBody>
       </p:sp>
       <p:cxnSp>
         <p:nvCxnSpPr>
-          <p:cNvPr id="17" name="Straight Arrow Connector 16">
-            <a:extLst>
-              <a:ext uri="{FF2B5EF4-FFF2-40B4-BE49-F238E27FC236}">
-                <a16:creationId xmlns:a16="http://schemas.microsoft.com/office/drawing/2014/main" id="{E449D956-F69C-CC61-73A7-CC405841B9AA}"/>
+          <p:cNvPr id="22" name="Straight Arrow Connector 21">
+            <a:extLst>
+              <a:ext uri="{FF2B5EF4-FFF2-40B4-BE49-F238E27FC236}">
+                <a16:creationId xmlns:a16="http://schemas.microsoft.com/office/drawing/2014/main" id="{D581F230-F5B9-7AEF-F868-226AC7353663}"/>
               </a:ext>
             </a:extLst>
           </p:cNvPr>
@@ -3714,9 +3658,9 @@
           <p:nvPr/>
         </p:nvCxnSpPr>
         <p:spPr>
-          <a:xfrm flipV="1">
-            <a:off x="1896533" y="2731911"/>
-            <a:ext cx="0" cy="1577624"/>
+          <a:xfrm>
+            <a:off x="2472267" y="2147889"/>
+            <a:ext cx="1259419" cy="0"/>
           </a:xfrm>
           <a:prstGeom prst="straightConnector1">
             <a:avLst/>
@@ -3745,10 +3689,10 @@
       </p:cxnSp>
       <p:sp>
         <p:nvSpPr>
-          <p:cNvPr id="19" name="TextBox 18">
-            <a:extLst>
-              <a:ext uri="{FF2B5EF4-FFF2-40B4-BE49-F238E27FC236}">
-                <a16:creationId xmlns:a16="http://schemas.microsoft.com/office/drawing/2014/main" id="{A4A6D4D8-0043-1B87-B94F-B5640A2CB096}"/>
+          <p:cNvPr id="23" name="TextBox 22">
+            <a:extLst>
+              <a:ext uri="{FF2B5EF4-FFF2-40B4-BE49-F238E27FC236}">
+                <a16:creationId xmlns:a16="http://schemas.microsoft.com/office/drawing/2014/main" id="{AE7E9D70-B2CB-D0A4-2653-D054881E6327}"/>
               </a:ext>
             </a:extLst>
           </p:cNvPr>
@@ -3757,8 +3701,8 @@
         </p:nvSpPr>
         <p:spPr>
           <a:xfrm>
-            <a:off x="1896533" y="3362350"/>
-            <a:ext cx="1625600" cy="307777"/>
+            <a:off x="2575971" y="1381233"/>
+            <a:ext cx="3036709" cy="523220"/>
           </a:xfrm>
           <a:prstGeom prst="rect">
             <a:avLst/>
@@ -3771,24 +3715,79 @@
           </a:bodyPr>
           <a:lstStyle/>
           <a:p>
+            <a:pPr algn="ctr"/>
             <a:r>
               <a:rPr lang="en-GB" sz="1400" dirty="0"/>
-              <a:t>Read from </a:t>
-            </a:r>
-            <a:r>
-              <a:rPr lang="en-GB" sz="1400" dirty="0" err="1"/>
-              <a:t>db</a:t>
-            </a:r>
-            <a:endParaRPr lang="en-GB" sz="1400" dirty="0"/>
+              <a:t>Writes messages to Citation Internal Transition Topic (CITT)</a:t>
+            </a:r>
+          </a:p>
+        </p:txBody>
+      </p:sp>
+      <p:sp>
+        <p:nvSpPr>
+          <p:cNvPr id="14" name="Rectangle 13">
+            <a:extLst>
+              <a:ext uri="{FF2B5EF4-FFF2-40B4-BE49-F238E27FC236}">
+                <a16:creationId xmlns:a16="http://schemas.microsoft.com/office/drawing/2014/main" id="{B26F9C71-3748-A460-DBF4-F0532FBB5164}"/>
+              </a:ext>
+            </a:extLst>
+          </p:cNvPr>
+          <p:cNvSpPr/>
+          <p:nvPr/>
+        </p:nvSpPr>
+        <p:spPr>
+          <a:xfrm>
+            <a:off x="4108446" y="3805165"/>
+            <a:ext cx="1005426" cy="369332"/>
+          </a:xfrm>
+          <a:prstGeom prst="rect">
+            <a:avLst/>
+          </a:prstGeom>
+          <a:noFill/>
+          <a:ln>
+            <a:solidFill>
+              <a:srgbClr val="00B0F0"/>
+            </a:solidFill>
+          </a:ln>
+        </p:spPr>
+        <p:style>
+          <a:lnRef idx="2">
+            <a:schemeClr val="accent1">
+              <a:shade val="15000"/>
+            </a:schemeClr>
+          </a:lnRef>
+          <a:fillRef idx="1">
+            <a:schemeClr val="accent1"/>
+          </a:fillRef>
+          <a:effectRef idx="0">
+            <a:schemeClr val="accent1"/>
+          </a:effectRef>
+          <a:fontRef idx="minor">
+            <a:schemeClr val="lt1"/>
+          </a:fontRef>
+        </p:style>
+        <p:txBody>
+          <a:bodyPr rtlCol="0" anchor="ctr"/>
+          <a:lstStyle/>
+          <a:p>
+            <a:pPr algn="ctr"/>
+            <a:r>
+              <a:rPr lang="en-GB" sz="1100" dirty="0">
+                <a:solidFill>
+                  <a:sysClr val="windowText" lastClr="000000"/>
+                </a:solidFill>
+              </a:rPr>
+              <a:t>Event Listener</a:t>
+            </a:r>
           </a:p>
         </p:txBody>
       </p:sp>
       <p:cxnSp>
         <p:nvCxnSpPr>
-          <p:cNvPr id="22" name="Straight Arrow Connector 21">
-            <a:extLst>
-              <a:ext uri="{FF2B5EF4-FFF2-40B4-BE49-F238E27FC236}">
-                <a16:creationId xmlns:a16="http://schemas.microsoft.com/office/drawing/2014/main" id="{D581F230-F5B9-7AEF-F868-226AC7353663}"/>
+          <p:cNvPr id="16" name="Straight Arrow Connector 15">
+            <a:extLst>
+              <a:ext uri="{FF2B5EF4-FFF2-40B4-BE49-F238E27FC236}">
+                <a16:creationId xmlns:a16="http://schemas.microsoft.com/office/drawing/2014/main" id="{2C265799-BB27-F5BB-748A-25F87B2B208E}"/>
               </a:ext>
             </a:extLst>
           </p:cNvPr>
@@ -3798,9 +3797,9 @@
           <p:nvPr/>
         </p:nvCxnSpPr>
         <p:spPr>
-          <a:xfrm>
-            <a:off x="2472267" y="2147889"/>
-            <a:ext cx="1259419" cy="0"/>
+          <a:xfrm flipH="1">
+            <a:off x="4278490" y="2145245"/>
+            <a:ext cx="1253066" cy="0"/>
           </a:xfrm>
           <a:prstGeom prst="straightConnector1">
             <a:avLst/>
@@ -3829,10 +3828,10 @@
       </p:cxnSp>
       <p:sp>
         <p:nvSpPr>
-          <p:cNvPr id="23" name="TextBox 22">
-            <a:extLst>
-              <a:ext uri="{FF2B5EF4-FFF2-40B4-BE49-F238E27FC236}">
-                <a16:creationId xmlns:a16="http://schemas.microsoft.com/office/drawing/2014/main" id="{AE7E9D70-B2CB-D0A4-2653-D054881E6327}"/>
+          <p:cNvPr id="26" name="TextBox 25">
+            <a:extLst>
+              <a:ext uri="{FF2B5EF4-FFF2-40B4-BE49-F238E27FC236}">
+                <a16:creationId xmlns:a16="http://schemas.microsoft.com/office/drawing/2014/main" id="{C9BE49BC-C1F5-86AB-FB04-696AC96997A8}"/>
               </a:ext>
             </a:extLst>
           </p:cNvPr>
@@ -3841,8 +3840,8 @@
         </p:nvSpPr>
         <p:spPr>
           <a:xfrm>
-            <a:off x="2580927" y="1615393"/>
-            <a:ext cx="3036709" cy="307777"/>
+            <a:off x="3731686" y="2687183"/>
+            <a:ext cx="1625601" cy="369332"/>
           </a:xfrm>
           <a:prstGeom prst="rect">
             <a:avLst/>
@@ -3850,83 +3849,29 @@
           <a:noFill/>
         </p:spPr>
         <p:txBody>
-          <a:bodyPr wrap="square" rtlCol="0">
+          <a:bodyPr wrap="square">
             <a:spAutoFit/>
           </a:bodyPr>
           <a:lstStyle/>
           <a:p>
-            <a:r>
-              <a:rPr lang="en-GB" sz="1400" dirty="0"/>
-              <a:t>Writes messages to Event Stream</a:t>
-            </a:r>
-          </a:p>
-        </p:txBody>
-      </p:sp>
-      <p:sp>
-        <p:nvSpPr>
-          <p:cNvPr id="14" name="Rectangle 13">
-            <a:extLst>
-              <a:ext uri="{FF2B5EF4-FFF2-40B4-BE49-F238E27FC236}">
-                <a16:creationId xmlns:a16="http://schemas.microsoft.com/office/drawing/2014/main" id="{B26F9C71-3748-A460-DBF4-F0532FBB5164}"/>
-              </a:ext>
-            </a:extLst>
-          </p:cNvPr>
-          <p:cNvSpPr/>
-          <p:nvPr/>
-        </p:nvSpPr>
-        <p:spPr>
-          <a:xfrm>
-            <a:off x="4108446" y="3805165"/>
-            <a:ext cx="1005426" cy="369332"/>
-          </a:xfrm>
-          <a:prstGeom prst="rect">
-            <a:avLst/>
-          </a:prstGeom>
-          <a:noFill/>
-          <a:ln>
-            <a:solidFill>
-              <a:srgbClr val="00B0F0"/>
-            </a:solidFill>
-          </a:ln>
-        </p:spPr>
-        <p:style>
-          <a:lnRef idx="2">
-            <a:schemeClr val="accent1">
-              <a:shade val="15000"/>
-            </a:schemeClr>
-          </a:lnRef>
-          <a:fillRef idx="1">
-            <a:schemeClr val="accent1"/>
-          </a:fillRef>
-          <a:effectRef idx="0">
-            <a:schemeClr val="accent1"/>
-          </a:effectRef>
-          <a:fontRef idx="minor">
-            <a:schemeClr val="lt1"/>
-          </a:fontRef>
-        </p:style>
-        <p:txBody>
-          <a:bodyPr rtlCol="0" anchor="ctr"/>
-          <a:lstStyle/>
-          <a:p>
             <a:pPr algn="ctr"/>
             <a:r>
-              <a:rPr lang="en-GB" sz="1100" dirty="0">
+              <a:rPr lang="en-GB" dirty="0">
                 <a:solidFill>
                   <a:sysClr val="windowText" lastClr="000000"/>
                 </a:solidFill>
               </a:rPr>
-              <a:t>Event Listener</a:t>
+              <a:t>Stream B</a:t>
             </a:r>
           </a:p>
         </p:txBody>
       </p:sp>
       <p:cxnSp>
         <p:nvCxnSpPr>
-          <p:cNvPr id="16" name="Straight Arrow Connector 15">
-            <a:extLst>
-              <a:ext uri="{FF2B5EF4-FFF2-40B4-BE49-F238E27FC236}">
-                <a16:creationId xmlns:a16="http://schemas.microsoft.com/office/drawing/2014/main" id="{2C265799-BB27-F5BB-748A-25F87B2B208E}"/>
+          <p:cNvPr id="28" name="Straight Arrow Connector 27">
+            <a:extLst>
+              <a:ext uri="{FF2B5EF4-FFF2-40B4-BE49-F238E27FC236}">
+                <a16:creationId xmlns:a16="http://schemas.microsoft.com/office/drawing/2014/main" id="{26537DA7-408A-DB4F-2325-88CF01DB96B8}"/>
               </a:ext>
             </a:extLst>
           </p:cNvPr>
@@ -3936,9 +3881,9 @@
           <p:nvPr/>
         </p:nvCxnSpPr>
         <p:spPr>
-          <a:xfrm flipH="1">
-            <a:off x="4278490" y="2145245"/>
-            <a:ext cx="1253066" cy="0"/>
+          <a:xfrm flipV="1">
+            <a:off x="6141154" y="3056515"/>
+            <a:ext cx="0" cy="1247125"/>
           </a:xfrm>
           <a:prstGeom prst="straightConnector1">
             <a:avLst/>
@@ -3967,10 +3912,10 @@
       </p:cxnSp>
       <p:sp>
         <p:nvSpPr>
-          <p:cNvPr id="26" name="TextBox 25">
-            <a:extLst>
-              <a:ext uri="{FF2B5EF4-FFF2-40B4-BE49-F238E27FC236}">
-                <a16:creationId xmlns:a16="http://schemas.microsoft.com/office/drawing/2014/main" id="{C9BE49BC-C1F5-86AB-FB04-696AC96997A8}"/>
+          <p:cNvPr id="29" name="TextBox 28">
+            <a:extLst>
+              <a:ext uri="{FF2B5EF4-FFF2-40B4-BE49-F238E27FC236}">
+                <a16:creationId xmlns:a16="http://schemas.microsoft.com/office/drawing/2014/main" id="{F4355D97-3304-B31A-E607-DA2FF4C350A0}"/>
               </a:ext>
             </a:extLst>
           </p:cNvPr>
@@ -3979,8 +3924,8 @@
         </p:nvSpPr>
         <p:spPr>
           <a:xfrm>
-            <a:off x="3731686" y="2687183"/>
-            <a:ext cx="1625601" cy="369332"/>
+            <a:off x="6141154" y="3356455"/>
+            <a:ext cx="1625600" cy="307777"/>
           </a:xfrm>
           <a:prstGeom prst="rect">
             <a:avLst/>
@@ -3988,29 +3933,29 @@
           <a:noFill/>
         </p:spPr>
         <p:txBody>
-          <a:bodyPr wrap="square">
+          <a:bodyPr wrap="square" rtlCol="0">
             <a:spAutoFit/>
           </a:bodyPr>
           <a:lstStyle/>
           <a:p>
-            <a:pPr algn="ctr"/>
-            <a:r>
-              <a:rPr lang="en-GB" dirty="0">
-                <a:solidFill>
-                  <a:sysClr val="windowText" lastClr="000000"/>
-                </a:solidFill>
-              </a:rPr>
-              <a:t>Stream B</a:t>
-            </a:r>
+            <a:r>
+              <a:rPr lang="en-GB" sz="1400" dirty="0"/>
+              <a:t>Read from </a:t>
+            </a:r>
+            <a:r>
+              <a:rPr lang="en-GB" sz="1400" dirty="0" err="1"/>
+              <a:t>db</a:t>
+            </a:r>
+            <a:endParaRPr lang="en-GB" sz="1400" dirty="0"/>
           </a:p>
         </p:txBody>
       </p:sp>
       <p:cxnSp>
         <p:nvCxnSpPr>
-          <p:cNvPr id="28" name="Straight Arrow Connector 27">
-            <a:extLst>
-              <a:ext uri="{FF2B5EF4-FFF2-40B4-BE49-F238E27FC236}">
-                <a16:creationId xmlns:a16="http://schemas.microsoft.com/office/drawing/2014/main" id="{26537DA7-408A-DB4F-2325-88CF01DB96B8}"/>
+          <p:cNvPr id="31" name="Straight Arrow Connector 30">
+            <a:extLst>
+              <a:ext uri="{FF2B5EF4-FFF2-40B4-BE49-F238E27FC236}">
+                <a16:creationId xmlns:a16="http://schemas.microsoft.com/office/drawing/2014/main" id="{3DC6C3E5-1ADB-E87F-AE7A-17961B3771DF}"/>
               </a:ext>
             </a:extLst>
           </p:cNvPr>
@@ -4020,9 +3965,9 @@
           <p:nvPr/>
         </p:nvCxnSpPr>
         <p:spPr>
-          <a:xfrm flipV="1">
-            <a:off x="6141154" y="2726016"/>
-            <a:ext cx="0" cy="1577624"/>
+          <a:xfrm>
+            <a:off x="3995553" y="1923170"/>
+            <a:ext cx="0" cy="1881995"/>
           </a:xfrm>
           <a:prstGeom prst="straightConnector1">
             <a:avLst/>
@@ -4049,64 +3994,25 @@
           </a:fontRef>
         </p:style>
       </p:cxnSp>
-      <p:sp>
-        <p:nvSpPr>
-          <p:cNvPr id="29" name="TextBox 28">
-            <a:extLst>
-              <a:ext uri="{FF2B5EF4-FFF2-40B4-BE49-F238E27FC236}">
-                <a16:creationId xmlns:a16="http://schemas.microsoft.com/office/drawing/2014/main" id="{F4355D97-3304-B31A-E607-DA2FF4C350A0}"/>
-              </a:ext>
-            </a:extLst>
-          </p:cNvPr>
-          <p:cNvSpPr txBox="1"/>
-          <p:nvPr/>
-        </p:nvSpPr>
-        <p:spPr>
-          <a:xfrm>
-            <a:off x="6141154" y="3356455"/>
-            <a:ext cx="1625600" cy="307777"/>
-          </a:xfrm>
-          <a:prstGeom prst="rect">
-            <a:avLst/>
-          </a:prstGeom>
-          <a:noFill/>
-        </p:spPr>
-        <p:txBody>
-          <a:bodyPr wrap="square" rtlCol="0">
-            <a:spAutoFit/>
-          </a:bodyPr>
-          <a:lstStyle/>
-          <a:p>
-            <a:r>
-              <a:rPr lang="en-GB" sz="1400" dirty="0"/>
-              <a:t>Read from </a:t>
-            </a:r>
-            <a:r>
-              <a:rPr lang="en-GB" sz="1400" dirty="0" err="1"/>
-              <a:t>db</a:t>
-            </a:r>
-            <a:endParaRPr lang="en-GB" sz="1400" dirty="0"/>
-          </a:p>
-        </p:txBody>
-      </p:sp>
       <p:cxnSp>
         <p:nvCxnSpPr>
-          <p:cNvPr id="31" name="Straight Arrow Connector 30">
-            <a:extLst>
-              <a:ext uri="{FF2B5EF4-FFF2-40B4-BE49-F238E27FC236}">
-                <a16:creationId xmlns:a16="http://schemas.microsoft.com/office/drawing/2014/main" id="{3DC6C3E5-1ADB-E87F-AE7A-17961B3771DF}"/>
+          <p:cNvPr id="38" name="Straight Arrow Connector 37">
+            <a:extLst>
+              <a:ext uri="{FF2B5EF4-FFF2-40B4-BE49-F238E27FC236}">
+                <a16:creationId xmlns:a16="http://schemas.microsoft.com/office/drawing/2014/main" id="{65A79A4B-3477-C407-547B-92DE4BC9372C}"/>
               </a:ext>
             </a:extLst>
           </p:cNvPr>
           <p:cNvCxnSpPr>
             <a:cxnSpLocks/>
+            <a:stCxn id="14" idx="3"/>
           </p:cNvCxnSpPr>
           <p:nvPr/>
         </p:nvCxnSpPr>
         <p:spPr>
           <a:xfrm>
-            <a:off x="3995553" y="1923170"/>
-            <a:ext cx="0" cy="1881995"/>
+            <a:off x="5113872" y="3989831"/>
+            <a:ext cx="495994" cy="373325"/>
           </a:xfrm>
           <a:prstGeom prst="straightConnector1">
             <a:avLst/>
@@ -4133,84 +4039,24 @@
           </a:fontRef>
         </p:style>
       </p:cxnSp>
-      <p:sp>
-        <p:nvSpPr>
-          <p:cNvPr id="37" name="Rectangle 36">
-            <a:extLst>
-              <a:ext uri="{FF2B5EF4-FFF2-40B4-BE49-F238E27FC236}">
-                <a16:creationId xmlns:a16="http://schemas.microsoft.com/office/drawing/2014/main" id="{92E276B7-11BB-3A2E-D9C9-441028D3B0BA}"/>
-              </a:ext>
-            </a:extLst>
-          </p:cNvPr>
-          <p:cNvSpPr/>
-          <p:nvPr/>
-        </p:nvSpPr>
-        <p:spPr>
-          <a:xfrm>
-            <a:off x="2865949" y="3805165"/>
-            <a:ext cx="1005426" cy="369332"/>
-          </a:xfrm>
-          <a:prstGeom prst="rect">
-            <a:avLst/>
-          </a:prstGeom>
-          <a:noFill/>
-          <a:ln>
-            <a:solidFill>
-              <a:srgbClr val="00B0F0"/>
-            </a:solidFill>
-          </a:ln>
-        </p:spPr>
-        <p:style>
-          <a:lnRef idx="2">
-            <a:schemeClr val="accent1">
-              <a:shade val="15000"/>
-            </a:schemeClr>
-          </a:lnRef>
-          <a:fillRef idx="1">
-            <a:schemeClr val="accent1"/>
-          </a:fillRef>
-          <a:effectRef idx="0">
-            <a:schemeClr val="accent1"/>
-          </a:effectRef>
-          <a:fontRef idx="minor">
-            <a:schemeClr val="lt1"/>
-          </a:fontRef>
-        </p:style>
-        <p:txBody>
-          <a:bodyPr rtlCol="0" anchor="ctr"/>
-          <a:lstStyle/>
-          <a:p>
-            <a:pPr algn="ctr"/>
-            <a:r>
-              <a:rPr lang="en-GB" sz="1100" dirty="0">
-                <a:solidFill>
-                  <a:sysClr val="windowText" lastClr="000000"/>
-                </a:solidFill>
-              </a:rPr>
-              <a:t>Event Listener</a:t>
-            </a:r>
-          </a:p>
-        </p:txBody>
-      </p:sp>
       <p:cxnSp>
         <p:nvCxnSpPr>
-          <p:cNvPr id="38" name="Straight Arrow Connector 37">
-            <a:extLst>
-              <a:ext uri="{FF2B5EF4-FFF2-40B4-BE49-F238E27FC236}">
-                <a16:creationId xmlns:a16="http://schemas.microsoft.com/office/drawing/2014/main" id="{65A79A4B-3477-C407-547B-92DE4BC9372C}"/>
+          <p:cNvPr id="45" name="Straight Arrow Connector 44">
+            <a:extLst>
+              <a:ext uri="{FF2B5EF4-FFF2-40B4-BE49-F238E27FC236}">
+                <a16:creationId xmlns:a16="http://schemas.microsoft.com/office/drawing/2014/main" id="{B2B8EDE0-ADB0-BF28-E1C9-2E526ACDB7AE}"/>
               </a:ext>
             </a:extLst>
           </p:cNvPr>
           <p:cNvCxnSpPr>
             <a:cxnSpLocks/>
-            <a:stCxn id="14" idx="3"/>
           </p:cNvCxnSpPr>
           <p:nvPr/>
         </p:nvCxnSpPr>
         <p:spPr>
-          <a:xfrm>
-            <a:off x="5113872" y="3989831"/>
-            <a:ext cx="495994" cy="373325"/>
+          <a:xfrm flipH="1">
+            <a:off x="6217920" y="498755"/>
+            <a:ext cx="1548834" cy="1456563"/>
           </a:xfrm>
           <a:prstGeom prst="straightConnector1">
             <a:avLst/>
@@ -4237,25 +4083,189 @@
           </a:fontRef>
         </p:style>
       </p:cxnSp>
+      <p:sp>
+        <p:nvSpPr>
+          <p:cNvPr id="48" name="TextBox 47">
+            <a:extLst>
+              <a:ext uri="{FF2B5EF4-FFF2-40B4-BE49-F238E27FC236}">
+                <a16:creationId xmlns:a16="http://schemas.microsoft.com/office/drawing/2014/main" id="{5E9EFF90-A849-8FB5-A1EC-6AE73916BFDD}"/>
+              </a:ext>
+            </a:extLst>
+          </p:cNvPr>
+          <p:cNvSpPr txBox="1"/>
+          <p:nvPr/>
+        </p:nvSpPr>
+        <p:spPr>
+          <a:xfrm>
+            <a:off x="7879646" y="305457"/>
+            <a:ext cx="2768835" cy="369332"/>
+          </a:xfrm>
+          <a:prstGeom prst="rect">
+            <a:avLst/>
+          </a:prstGeom>
+          <a:noFill/>
+        </p:spPr>
+        <p:txBody>
+          <a:bodyPr wrap="none" rtlCol="0">
+            <a:spAutoFit/>
+          </a:bodyPr>
+          <a:lstStyle/>
+          <a:p>
+            <a:r>
+              <a:rPr lang="en-GB" dirty="0"/>
+              <a:t>API queries from Stream A</a:t>
+            </a:r>
+          </a:p>
+        </p:txBody>
+      </p:sp>
+      <p:sp>
+        <p:nvSpPr>
+          <p:cNvPr id="3" name="TextBox 2">
+            <a:extLst>
+              <a:ext uri="{FF2B5EF4-FFF2-40B4-BE49-F238E27FC236}">
+                <a16:creationId xmlns:a16="http://schemas.microsoft.com/office/drawing/2014/main" id="{2627CE90-D37F-6FA5-659C-8DE95ED363B9}"/>
+              </a:ext>
+            </a:extLst>
+          </p:cNvPr>
+          <p:cNvSpPr txBox="1"/>
+          <p:nvPr/>
+        </p:nvSpPr>
+        <p:spPr>
+          <a:xfrm>
+            <a:off x="7690561" y="1670818"/>
+            <a:ext cx="4130312" cy="3954929"/>
+          </a:xfrm>
+          <a:prstGeom prst="rect">
+            <a:avLst/>
+          </a:prstGeom>
+          <a:noFill/>
+        </p:spPr>
+        <p:txBody>
+          <a:bodyPr wrap="square" rtlCol="0">
+            <a:spAutoFit/>
+          </a:bodyPr>
+          <a:lstStyle/>
+          <a:p>
+            <a:pPr marL="285750" indent="-285750">
+              <a:spcAft>
+                <a:spcPts val="600"/>
+              </a:spcAft>
+              <a:buFont typeface="Arial" panose="020B0604020202020204" pitchFamily="34" charset="0"/>
+              <a:buChar char="•"/>
+            </a:pPr>
+            <a:r>
+              <a:rPr lang="en-GB" dirty="0"/>
+              <a:t>Standardise the messages to the event stream.</a:t>
+            </a:r>
+          </a:p>
+          <a:p>
+            <a:pPr marL="285750" indent="-285750">
+              <a:spcAft>
+                <a:spcPts val="600"/>
+              </a:spcAft>
+              <a:buFont typeface="Arial" panose="020B0604020202020204" pitchFamily="34" charset="0"/>
+              <a:buChar char="•"/>
+            </a:pPr>
+            <a:r>
+              <a:rPr lang="en-GB" dirty="0"/>
+              <a:t>Specific topic for citation service updates</a:t>
+            </a:r>
+          </a:p>
+          <a:p>
+            <a:pPr marL="285750" indent="-285750">
+              <a:spcAft>
+                <a:spcPts val="600"/>
+              </a:spcAft>
+              <a:buFont typeface="Arial" panose="020B0604020202020204" pitchFamily="34" charset="0"/>
+              <a:buChar char="•"/>
+            </a:pPr>
+            <a:r>
+              <a:rPr lang="en-GB" dirty="0"/>
+              <a:t>CREATE (serialised model)</a:t>
+            </a:r>
+          </a:p>
+          <a:p>
+            <a:pPr marL="285750" indent="-285750">
+              <a:spcAft>
+                <a:spcPts val="600"/>
+              </a:spcAft>
+              <a:buFont typeface="Arial" panose="020B0604020202020204" pitchFamily="34" charset="0"/>
+              <a:buChar char="•"/>
+            </a:pPr>
+            <a:r>
+              <a:rPr lang="en-GB" dirty="0"/>
+              <a:t>UPDATE (serialised model)</a:t>
+            </a:r>
+          </a:p>
+          <a:p>
+            <a:pPr marL="285750" indent="-285750">
+              <a:spcAft>
+                <a:spcPts val="600"/>
+              </a:spcAft>
+              <a:buFont typeface="Arial" panose="020B0604020202020204" pitchFamily="34" charset="0"/>
+              <a:buChar char="•"/>
+            </a:pPr>
+            <a:r>
+              <a:rPr lang="en-GB" dirty="0"/>
+              <a:t>DELETE (model ID)</a:t>
+            </a:r>
+          </a:p>
+          <a:p>
+            <a:pPr marL="285750" indent="-285750">
+              <a:spcAft>
+                <a:spcPts val="600"/>
+              </a:spcAft>
+              <a:buFont typeface="Arial" panose="020B0604020202020204" pitchFamily="34" charset="0"/>
+              <a:buChar char="•"/>
+            </a:pPr>
+            <a:r>
+              <a:rPr lang="en-GB" dirty="0"/>
+              <a:t>Read directly from the database (Pseudo-read-only)</a:t>
+            </a:r>
+          </a:p>
+          <a:p>
+            <a:pPr marL="285750" indent="-285750">
+              <a:spcAft>
+                <a:spcPts val="600"/>
+              </a:spcAft>
+              <a:buFont typeface="Arial" panose="020B0604020202020204" pitchFamily="34" charset="0"/>
+              <a:buChar char="•"/>
+            </a:pPr>
+            <a:endParaRPr lang="en-GB" dirty="0"/>
+          </a:p>
+          <a:p>
+            <a:pPr marL="285750" indent="-285750">
+              <a:spcAft>
+                <a:spcPts val="600"/>
+              </a:spcAft>
+              <a:buFont typeface="Arial" panose="020B0604020202020204" pitchFamily="34" charset="0"/>
+              <a:buChar char="•"/>
+            </a:pPr>
+            <a:r>
+              <a:rPr lang="en-GB" dirty="0"/>
+              <a:t>Await response from Kafka listener before proceeding.</a:t>
+            </a:r>
+          </a:p>
+        </p:txBody>
+      </p:sp>
       <p:cxnSp>
         <p:nvCxnSpPr>
-          <p:cNvPr id="42" name="Straight Arrow Connector 41">
-            <a:extLst>
-              <a:ext uri="{FF2B5EF4-FFF2-40B4-BE49-F238E27FC236}">
-                <a16:creationId xmlns:a16="http://schemas.microsoft.com/office/drawing/2014/main" id="{D26810FD-1A1F-1A5B-32E4-DB3363737FB8}"/>
+          <p:cNvPr id="8" name="Straight Arrow Connector 7">
+            <a:extLst>
+              <a:ext uri="{FF2B5EF4-FFF2-40B4-BE49-F238E27FC236}">
+                <a16:creationId xmlns:a16="http://schemas.microsoft.com/office/drawing/2014/main" id="{D67775E8-E886-324B-9A07-A3EA812E91F2}"/>
               </a:ext>
             </a:extLst>
           </p:cNvPr>
           <p:cNvCxnSpPr>
             <a:cxnSpLocks/>
-            <a:stCxn id="37" idx="1"/>
           </p:cNvCxnSpPr>
           <p:nvPr/>
         </p:nvCxnSpPr>
         <p:spPr>
           <a:xfrm flipH="1">
-            <a:off x="2398877" y="3989831"/>
-            <a:ext cx="467072" cy="386757"/>
+            <a:off x="2472267" y="2335124"/>
+            <a:ext cx="1259419" cy="0"/>
           </a:xfrm>
           <a:prstGeom prst="straightConnector1">
             <a:avLst/>
@@ -4282,91 +4292,68 @@
           </a:fontRef>
         </p:style>
       </p:cxnSp>
-      <p:cxnSp>
-        <p:nvCxnSpPr>
-          <p:cNvPr id="45" name="Straight Arrow Connector 44">
-            <a:extLst>
-              <a:ext uri="{FF2B5EF4-FFF2-40B4-BE49-F238E27FC236}">
-                <a16:creationId xmlns:a16="http://schemas.microsoft.com/office/drawing/2014/main" id="{B2B8EDE0-ADB0-BF28-E1C9-2E526ACDB7AE}"/>
-              </a:ext>
-            </a:extLst>
-          </p:cNvPr>
-          <p:cNvCxnSpPr>
-            <a:cxnSpLocks/>
-          </p:cNvCxnSpPr>
+      <p:sp>
+        <p:nvSpPr>
+          <p:cNvPr id="10" name="Rectangle 9">
+            <a:extLst>
+              <a:ext uri="{FF2B5EF4-FFF2-40B4-BE49-F238E27FC236}">
+                <a16:creationId xmlns:a16="http://schemas.microsoft.com/office/drawing/2014/main" id="{38A8B0FA-24DA-4853-9EF6-F4C014346ECB}"/>
+              </a:ext>
+            </a:extLst>
+          </p:cNvPr>
+          <p:cNvSpPr/>
           <p:nvPr/>
-        </p:nvCxnSpPr>
-        <p:spPr>
-          <a:xfrm flipH="1">
-            <a:off x="6321778" y="498755"/>
-            <a:ext cx="1444976" cy="1116638"/>
-          </a:xfrm>
-          <a:prstGeom prst="straightConnector1">
-            <a:avLst/>
-          </a:prstGeom>
-          <a:ln>
-            <a:solidFill>
-              <a:srgbClr val="00B0F0"/>
-            </a:solidFill>
-            <a:tailEnd type="triangle"/>
-          </a:ln>
-        </p:spPr>
-        <p:style>
-          <a:lnRef idx="2">
-            <a:schemeClr val="accent1"/>
-          </a:lnRef>
-          <a:fillRef idx="0">
-            <a:schemeClr val="accent1"/>
-          </a:fillRef>
-          <a:effectRef idx="1">
-            <a:schemeClr val="accent1"/>
-          </a:effectRef>
-          <a:fontRef idx="minor">
-            <a:schemeClr val="tx1"/>
-          </a:fontRef>
-        </p:style>
-      </p:cxnSp>
-      <p:sp>
-        <p:nvSpPr>
-          <p:cNvPr id="48" name="TextBox 47">
-            <a:extLst>
-              <a:ext uri="{FF2B5EF4-FFF2-40B4-BE49-F238E27FC236}">
-                <a16:creationId xmlns:a16="http://schemas.microsoft.com/office/drawing/2014/main" id="{5E9EFF90-A849-8FB5-A1EC-6AE73916BFDD}"/>
-              </a:ext>
-            </a:extLst>
-          </p:cNvPr>
-          <p:cNvSpPr txBox="1"/>
-          <p:nvPr/>
         </p:nvSpPr>
         <p:spPr>
           <a:xfrm>
-            <a:off x="7879646" y="305457"/>
-            <a:ext cx="2768835" cy="369332"/>
+            <a:off x="4057486" y="1923170"/>
+            <a:ext cx="3598322" cy="3553597"/>
           </a:xfrm>
           <a:prstGeom prst="rect">
             <a:avLst/>
           </a:prstGeom>
           <a:noFill/>
-        </p:spPr>
-        <p:txBody>
-          <a:bodyPr wrap="none" rtlCol="0">
-            <a:spAutoFit/>
-          </a:bodyPr>
-          <a:lstStyle/>
-          <a:p>
-            <a:r>
-              <a:rPr lang="en-GB" dirty="0"/>
-              <a:t>API queries from Stream A</a:t>
-            </a:r>
-          </a:p>
-        </p:txBody>
-      </p:sp>
-      <p:sp>
-        <p:nvSpPr>
-          <p:cNvPr id="3" name="TextBox 2">
-            <a:extLst>
-              <a:ext uri="{FF2B5EF4-FFF2-40B4-BE49-F238E27FC236}">
-                <a16:creationId xmlns:a16="http://schemas.microsoft.com/office/drawing/2014/main" id="{2627CE90-D37F-6FA5-659C-8DE95ED363B9}"/>
+          <a:ln>
+            <a:solidFill>
+              <a:schemeClr val="accent6">
+                <a:lumMod val="60000"/>
+                <a:lumOff val="40000"/>
+              </a:schemeClr>
+            </a:solidFill>
+            <a:prstDash val="lgDash"/>
+          </a:ln>
+        </p:spPr>
+        <p:style>
+          <a:lnRef idx="2">
+            <a:schemeClr val="accent1">
+              <a:shade val="15000"/>
+            </a:schemeClr>
+          </a:lnRef>
+          <a:fillRef idx="1">
+            <a:schemeClr val="accent1"/>
+          </a:fillRef>
+          <a:effectRef idx="0">
+            <a:schemeClr val="accent1"/>
+          </a:effectRef>
+          <a:fontRef idx="minor">
+            <a:schemeClr val="lt1"/>
+          </a:fontRef>
+        </p:style>
+        <p:txBody>
+          <a:bodyPr rtlCol="0" anchor="ctr"/>
+          <a:lstStyle/>
+          <a:p>
+            <a:pPr algn="ctr"/>
+            <a:endParaRPr lang="en-GB"/>
+          </a:p>
+        </p:txBody>
+      </p:sp>
+      <p:sp>
+        <p:nvSpPr>
+          <p:cNvPr id="15" name="TextBox 14">
+            <a:extLst>
+              <a:ext uri="{FF2B5EF4-FFF2-40B4-BE49-F238E27FC236}">
+                <a16:creationId xmlns:a16="http://schemas.microsoft.com/office/drawing/2014/main" id="{7179B833-03ED-15EA-DBD6-E469DEA9A19F}"/>
               </a:ext>
             </a:extLst>
           </p:cNvPr>
@@ -4375,8 +4362,8 @@
         </p:nvSpPr>
         <p:spPr>
           <a:xfrm>
-            <a:off x="7690561" y="1670818"/>
-            <a:ext cx="4130312" cy="3954929"/>
+            <a:off x="4057486" y="5157972"/>
+            <a:ext cx="2220160" cy="276999"/>
           </a:xfrm>
           <a:prstGeom prst="rect">
             <a:avLst/>
@@ -4384,109 +4371,14 @@
           <a:noFill/>
         </p:spPr>
         <p:txBody>
-          <a:bodyPr wrap="square" rtlCol="0">
+          <a:bodyPr wrap="none" rtlCol="0">
             <a:spAutoFit/>
           </a:bodyPr>
           <a:lstStyle/>
           <a:p>
-            <a:pPr marL="285750" indent="-285750">
-              <a:spcAft>
-                <a:spcPts val="600"/>
-              </a:spcAft>
-              <a:buFont typeface="Arial" panose="020B0604020202020204" pitchFamily="34" charset="0"/>
-              <a:buChar char="•"/>
-            </a:pPr>
-            <a:r>
-              <a:rPr lang="en-GB" dirty="0"/>
-              <a:t>Standardise the messages to the event stream.</a:t>
-            </a:r>
-          </a:p>
-          <a:p>
-            <a:pPr marL="285750" indent="-285750">
-              <a:spcAft>
-                <a:spcPts val="600"/>
-              </a:spcAft>
-              <a:buFont typeface="Arial" panose="020B0604020202020204" pitchFamily="34" charset="0"/>
-              <a:buChar char="•"/>
-            </a:pPr>
-            <a:r>
-              <a:rPr lang="en-GB" dirty="0"/>
-              <a:t>Specific topic for citation service updates</a:t>
-            </a:r>
-          </a:p>
-          <a:p>
-            <a:pPr marL="285750" indent="-285750">
-              <a:spcAft>
-                <a:spcPts val="600"/>
-              </a:spcAft>
-              <a:buFont typeface="Arial" panose="020B0604020202020204" pitchFamily="34" charset="0"/>
-              <a:buChar char="•"/>
-            </a:pPr>
-            <a:r>
-              <a:rPr lang="en-GB" dirty="0"/>
-              <a:t>CREATE (serialised model)</a:t>
-            </a:r>
-          </a:p>
-          <a:p>
-            <a:pPr marL="285750" indent="-285750">
-              <a:spcAft>
-                <a:spcPts val="600"/>
-              </a:spcAft>
-              <a:buFont typeface="Arial" panose="020B0604020202020204" pitchFamily="34" charset="0"/>
-              <a:buChar char="•"/>
-            </a:pPr>
-            <a:r>
-              <a:rPr lang="en-GB" dirty="0"/>
-              <a:t>UPDATE (serialised model)</a:t>
-            </a:r>
-          </a:p>
-          <a:p>
-            <a:pPr marL="285750" indent="-285750">
-              <a:spcAft>
-                <a:spcPts val="600"/>
-              </a:spcAft>
-              <a:buFont typeface="Arial" panose="020B0604020202020204" pitchFamily="34" charset="0"/>
-              <a:buChar char="•"/>
-            </a:pPr>
-            <a:r>
-              <a:rPr lang="en-GB" dirty="0"/>
-              <a:t>DELETE (model ID)</a:t>
-            </a:r>
-          </a:p>
-          <a:p>
-            <a:pPr marL="285750" indent="-285750">
-              <a:spcAft>
-                <a:spcPts val="600"/>
-              </a:spcAft>
-              <a:buFont typeface="Arial" panose="020B0604020202020204" pitchFamily="34" charset="0"/>
-              <a:buChar char="•"/>
-            </a:pPr>
-            <a:r>
-              <a:rPr lang="en-GB" dirty="0"/>
-              <a:t>Read directly from the database (Pseudo-read-only)</a:t>
-            </a:r>
-          </a:p>
-          <a:p>
-            <a:pPr marL="285750" indent="-285750">
-              <a:spcAft>
-                <a:spcPts val="600"/>
-              </a:spcAft>
-              <a:buFont typeface="Arial" panose="020B0604020202020204" pitchFamily="34" charset="0"/>
-              <a:buChar char="•"/>
-            </a:pPr>
-            <a:endParaRPr lang="en-GB" dirty="0"/>
-          </a:p>
-          <a:p>
-            <a:pPr marL="285750" indent="-285750">
-              <a:spcAft>
-                <a:spcPts val="600"/>
-              </a:spcAft>
-              <a:buFont typeface="Arial" panose="020B0604020202020204" pitchFamily="34" charset="0"/>
-              <a:buChar char="•"/>
-            </a:pPr>
-            <a:r>
-              <a:rPr lang="en-GB" dirty="0"/>
-              <a:t>Await response from Kafka listener before proceeding.</a:t>
+            <a:r>
+              <a:rPr lang="en-GB" sz="1200" dirty="0"/>
+              <a:t>Node-specific Implementation</a:t>
             </a:r>
           </a:p>
         </p:txBody>
@@ -4735,7 +4627,7 @@
                   <a:sysClr val="windowText" lastClr="000000"/>
                 </a:solidFill>
               </a:rPr>
-              <a:t>Citation Service Container</a:t>
+              <a:t>Citation SVC Frontend App</a:t>
             </a:r>
           </a:p>
         </p:txBody>
@@ -4794,7 +4686,7 @@
                   <a:sysClr val="windowText" lastClr="000000"/>
                 </a:solidFill>
               </a:rPr>
-              <a:t>ESL:A (Simple Parser)</a:t>
+              <a:t>Publication Listener</a:t>
             </a:r>
           </a:p>
         </p:txBody>
@@ -4902,7 +4794,7 @@
         <p:spPr>
           <a:xfrm>
             <a:off x="6237381" y="5179531"/>
-            <a:ext cx="3578031" cy="646331"/>
+            <a:ext cx="5291898" cy="646331"/>
           </a:xfrm>
           <a:prstGeom prst="rect">
             <a:avLst/>
@@ -4917,13 +4809,13 @@
           <a:p>
             <a:r>
               <a:rPr lang="en-GB" dirty="0"/>
-              <a:t>ESGF Publisher (CEDA)</a:t>
+              <a:t>Publication Listener</a:t>
             </a:r>
           </a:p>
           <a:p>
             <a:r>
               <a:rPr lang="en-GB" dirty="0"/>
-              <a:t>- Sends messages to event stream</a:t>
+              <a:t>– Listens to Success Topic for Published STAC Items</a:t>
             </a:r>
           </a:p>
         </p:txBody>
@@ -5330,7 +5222,7 @@
         <p:spPr>
           <a:xfrm>
             <a:off x="613830" y="3318517"/>
-            <a:ext cx="3059288" cy="2462213"/>
+            <a:ext cx="3059288" cy="1600438"/>
           </a:xfrm>
           <a:prstGeom prst="rect">
             <a:avLst/>
@@ -5349,7 +5241,7 @@
             </a:pPr>
             <a:r>
               <a:rPr lang="en-GB" sz="1400" dirty="0"/>
-              <a:t>Database hosted at CEDA or externally in the cloud?</a:t>
+              <a:t>Database hosted at CEDA for East Node (other nodes can have any other implementation.)</a:t>
             </a:r>
           </a:p>
           <a:p>
@@ -5366,44 +5258,15 @@
             </a:pPr>
             <a:r>
               <a:rPr lang="en-GB" sz="1400" dirty="0"/>
-              <a:t>Citation Service waits for confirmation on </a:t>
+              <a:t>Create/Update confirmation is </a:t>
             </a:r>
             <a:r>
               <a:rPr lang="en-GB" sz="1400" b="1" dirty="0"/>
-              <a:t>primary</a:t>
+              <a:t>NOT </a:t>
             </a:r>
             <a:r>
               <a:rPr lang="en-GB" sz="1400" dirty="0"/>
-              <a:t> model constructions</a:t>
-            </a:r>
-          </a:p>
-          <a:p>
-            <a:pPr marL="285750" indent="-285750">
-              <a:buFont typeface="Arial" panose="020B0604020202020204" pitchFamily="34" charset="0"/>
-              <a:buChar char="•"/>
-            </a:pPr>
-            <a:endParaRPr lang="en-GB" sz="1400" dirty="0"/>
-          </a:p>
-          <a:p>
-            <a:pPr marL="285750" indent="-285750">
-              <a:buFont typeface="Arial" panose="020B0604020202020204" pitchFamily="34" charset="0"/>
-              <a:buChar char="•"/>
-            </a:pPr>
-            <a:r>
-              <a:rPr lang="en-GB" sz="1400" b="1" dirty="0"/>
-              <a:t>Secondary</a:t>
-            </a:r>
-            <a:r>
-              <a:rPr lang="en-GB" sz="1400" dirty="0"/>
-              <a:t> model constructions – ones created </a:t>
-            </a:r>
-            <a:r>
-              <a:rPr lang="en-GB" sz="1400" i="1" dirty="0"/>
-              <a:t>as a result </a:t>
-            </a:r>
-            <a:r>
-              <a:rPr lang="en-GB" sz="1400" dirty="0"/>
-              <a:t>of a primary construction – are not waited upon.</a:t>
+              <a:t>awaited – redirects occur immediately.</a:t>
             </a:r>
           </a:p>
         </p:txBody>
@@ -5462,7 +5325,7 @@
                   <a:sysClr val="windowText" lastClr="000000"/>
                 </a:solidFill>
               </a:rPr>
-              <a:t>ESL:B (DB Read/Write)</a:t>
+              <a:t>Citation Backend Listener</a:t>
             </a:r>
           </a:p>
         </p:txBody>
@@ -5559,813 +5422,6 @@
     <p:extLst>
       <p:ext uri="{BB962C8B-B14F-4D97-AF65-F5344CB8AC3E}">
         <p14:creationId xmlns:p14="http://schemas.microsoft.com/office/powerpoint/2010/main" val="3575568463"/>
-      </p:ext>
-    </p:extLst>
-  </p:cSld>
-  <p:clrMapOvr>
-    <a:masterClrMapping/>
-  </p:clrMapOvr>
-</p:sld>
-</file>
-
-<file path=ppt/slides/slide4.xml><?xml version="1.0" encoding="utf-8"?>
-<p:sld xmlns:a="http://schemas.openxmlformats.org/drawingml/2006/main" xmlns:r="http://schemas.openxmlformats.org/officeDocument/2006/relationships" xmlns:p="http://schemas.openxmlformats.org/presentationml/2006/main">
-  <p:cSld>
-    <p:spTree>
-      <p:nvGrpSpPr>
-        <p:cNvPr id="1" name=""/>
-        <p:cNvGrpSpPr/>
-        <p:nvPr/>
-      </p:nvGrpSpPr>
-      <p:grpSpPr>
-        <a:xfrm>
-          <a:off x="0" y="0"/>
-          <a:ext cx="0" cy="0"/>
-          <a:chOff x="0" y="0"/>
-          <a:chExt cx="0" cy="0"/>
-        </a:xfrm>
-      </p:grpSpPr>
-      <p:sp>
-        <p:nvSpPr>
-          <p:cNvPr id="2" name="Title 1">
-            <a:extLst>
-              <a:ext uri="{FF2B5EF4-FFF2-40B4-BE49-F238E27FC236}">
-                <a16:creationId xmlns:a16="http://schemas.microsoft.com/office/drawing/2014/main" id="{485C415E-A951-5DD7-E05A-FDA3445E0110}"/>
-              </a:ext>
-            </a:extLst>
-          </p:cNvPr>
-          <p:cNvSpPr>
-            <a:spLocks noGrp="1"/>
-          </p:cNvSpPr>
-          <p:nvPr>
-            <p:ph type="title"/>
-          </p:nvPr>
-        </p:nvSpPr>
-        <p:spPr/>
-        <p:txBody>
-          <a:bodyPr/>
-          <a:lstStyle/>
-          <a:p>
-            <a:r>
-              <a:rPr lang="en-GB" dirty="0"/>
-              <a:t>Database Write Loop</a:t>
-            </a:r>
-          </a:p>
-        </p:txBody>
-      </p:sp>
-      <p:sp>
-        <p:nvSpPr>
-          <p:cNvPr id="4" name="Rectangle 3">
-            <a:extLst>
-              <a:ext uri="{FF2B5EF4-FFF2-40B4-BE49-F238E27FC236}">
-                <a16:creationId xmlns:a16="http://schemas.microsoft.com/office/drawing/2014/main" id="{C206C476-8E1F-E3AC-ABBE-7B95CAC4B7CA}"/>
-              </a:ext>
-            </a:extLst>
-          </p:cNvPr>
-          <p:cNvSpPr/>
-          <p:nvPr/>
-        </p:nvSpPr>
-        <p:spPr>
-          <a:xfrm>
-            <a:off x="4302477" y="3008047"/>
-            <a:ext cx="4397024" cy="2102379"/>
-          </a:xfrm>
-          <a:prstGeom prst="rect">
-            <a:avLst/>
-          </a:prstGeom>
-          <a:noFill/>
-          <a:ln>
-            <a:solidFill>
-              <a:srgbClr val="00B0F0"/>
-            </a:solidFill>
-            <a:prstDash val="dash"/>
-          </a:ln>
-        </p:spPr>
-        <p:style>
-          <a:lnRef idx="2">
-            <a:schemeClr val="accent1">
-              <a:shade val="15000"/>
-            </a:schemeClr>
-          </a:lnRef>
-          <a:fillRef idx="1">
-            <a:schemeClr val="accent1"/>
-          </a:fillRef>
-          <a:effectRef idx="0">
-            <a:schemeClr val="accent1"/>
-          </a:effectRef>
-          <a:fontRef idx="minor">
-            <a:schemeClr val="lt1"/>
-          </a:fontRef>
-        </p:style>
-        <p:txBody>
-          <a:bodyPr rtlCol="0" anchor="ctr"/>
-          <a:lstStyle/>
-          <a:p>
-            <a:pPr algn="ctr"/>
-            <a:r>
-              <a:rPr lang="en-GB" dirty="0">
-                <a:solidFill>
-                  <a:sysClr val="windowText" lastClr="000000"/>
-                </a:solidFill>
-              </a:rPr>
-              <a:t>Citation Service Deployment (k8s)</a:t>
-            </a:r>
-          </a:p>
-          <a:p>
-            <a:pPr algn="ctr"/>
-            <a:endParaRPr lang="en-GB" dirty="0">
-              <a:solidFill>
-                <a:sysClr val="windowText" lastClr="000000"/>
-              </a:solidFill>
-            </a:endParaRPr>
-          </a:p>
-          <a:p>
-            <a:pPr algn="ctr"/>
-            <a:endParaRPr lang="en-GB" dirty="0">
-              <a:solidFill>
-                <a:sysClr val="windowText" lastClr="000000"/>
-              </a:solidFill>
-            </a:endParaRPr>
-          </a:p>
-          <a:p>
-            <a:pPr algn="ctr"/>
-            <a:endParaRPr lang="en-GB" dirty="0">
-              <a:solidFill>
-                <a:sysClr val="windowText" lastClr="000000"/>
-              </a:solidFill>
-            </a:endParaRPr>
-          </a:p>
-          <a:p>
-            <a:pPr algn="ctr"/>
-            <a:endParaRPr lang="en-GB" dirty="0">
-              <a:solidFill>
-                <a:sysClr val="windowText" lastClr="000000"/>
-              </a:solidFill>
-            </a:endParaRPr>
-          </a:p>
-          <a:p>
-            <a:pPr algn="ctr"/>
-            <a:endParaRPr lang="en-GB" dirty="0">
-              <a:solidFill>
-                <a:sysClr val="windowText" lastClr="000000"/>
-              </a:solidFill>
-            </a:endParaRPr>
-          </a:p>
-          <a:p>
-            <a:pPr algn="ctr"/>
-            <a:endParaRPr lang="en-GB" dirty="0">
-              <a:solidFill>
-                <a:sysClr val="windowText" lastClr="000000"/>
-              </a:solidFill>
-            </a:endParaRPr>
-          </a:p>
-        </p:txBody>
-      </p:sp>
-      <p:sp>
-        <p:nvSpPr>
-          <p:cNvPr id="5" name="Rounded Rectangle 4">
-            <a:extLst>
-              <a:ext uri="{FF2B5EF4-FFF2-40B4-BE49-F238E27FC236}">
-                <a16:creationId xmlns:a16="http://schemas.microsoft.com/office/drawing/2014/main" id="{FDDE4D0F-55C8-3C12-E657-3D58F8DA96D2}"/>
-              </a:ext>
-            </a:extLst>
-          </p:cNvPr>
-          <p:cNvSpPr/>
-          <p:nvPr/>
-        </p:nvSpPr>
-        <p:spPr>
-          <a:xfrm>
-            <a:off x="4570589" y="3568170"/>
-            <a:ext cx="3860799" cy="394231"/>
-          </a:xfrm>
-          <a:prstGeom prst="roundRect">
-            <a:avLst/>
-          </a:prstGeom>
-          <a:noFill/>
-          <a:ln>
-            <a:solidFill>
-              <a:srgbClr val="00B0F0"/>
-            </a:solidFill>
-          </a:ln>
-        </p:spPr>
-        <p:style>
-          <a:lnRef idx="2">
-            <a:schemeClr val="accent1">
-              <a:shade val="15000"/>
-            </a:schemeClr>
-          </a:lnRef>
-          <a:fillRef idx="1">
-            <a:schemeClr val="accent1"/>
-          </a:fillRef>
-          <a:effectRef idx="0">
-            <a:schemeClr val="accent1"/>
-          </a:effectRef>
-          <a:fontRef idx="minor">
-            <a:schemeClr val="lt1"/>
-          </a:fontRef>
-        </p:style>
-        <p:txBody>
-          <a:bodyPr rtlCol="0" anchor="ctr"/>
-          <a:lstStyle/>
-          <a:p>
-            <a:pPr algn="ctr"/>
-            <a:r>
-              <a:rPr lang="en-GB" dirty="0">
-                <a:solidFill>
-                  <a:sysClr val="windowText" lastClr="000000"/>
-                </a:solidFill>
-              </a:rPr>
-              <a:t>Citation Service Container</a:t>
-            </a:r>
-          </a:p>
-        </p:txBody>
-      </p:sp>
-      <p:sp>
-        <p:nvSpPr>
-          <p:cNvPr id="6" name="Rounded Rectangle 5">
-            <a:extLst>
-              <a:ext uri="{FF2B5EF4-FFF2-40B4-BE49-F238E27FC236}">
-                <a16:creationId xmlns:a16="http://schemas.microsoft.com/office/drawing/2014/main" id="{B3BA9C9E-62A3-7F44-C521-E8C030455E76}"/>
-              </a:ext>
-            </a:extLst>
-          </p:cNvPr>
-          <p:cNvSpPr/>
-          <p:nvPr/>
-        </p:nvSpPr>
-        <p:spPr>
-          <a:xfrm>
-            <a:off x="4570588" y="4270136"/>
-            <a:ext cx="3860799" cy="646619"/>
-          </a:xfrm>
-          <a:prstGeom prst="roundRect">
-            <a:avLst/>
-          </a:prstGeom>
-          <a:noFill/>
-          <a:ln>
-            <a:solidFill>
-              <a:srgbClr val="00B0F0"/>
-            </a:solidFill>
-          </a:ln>
-        </p:spPr>
-        <p:style>
-          <a:lnRef idx="2">
-            <a:schemeClr val="accent1">
-              <a:shade val="15000"/>
-            </a:schemeClr>
-          </a:lnRef>
-          <a:fillRef idx="1">
-            <a:schemeClr val="accent1"/>
-          </a:fillRef>
-          <a:effectRef idx="0">
-            <a:schemeClr val="accent1"/>
-          </a:effectRef>
-          <a:fontRef idx="minor">
-            <a:schemeClr val="lt1"/>
-          </a:fontRef>
-        </p:style>
-        <p:txBody>
-          <a:bodyPr rtlCol="0" anchor="ctr"/>
-          <a:lstStyle/>
-          <a:p>
-            <a:pPr algn="ctr"/>
-            <a:r>
-              <a:rPr lang="en-GB" dirty="0">
-                <a:solidFill>
-                  <a:sysClr val="windowText" lastClr="000000"/>
-                </a:solidFill>
-              </a:rPr>
-              <a:t>Event Stream Listener A</a:t>
-            </a:r>
-          </a:p>
-          <a:p>
-            <a:pPr algn="ctr"/>
-            <a:r>
-              <a:rPr lang="en-GB" i="1" dirty="0">
-                <a:solidFill>
-                  <a:sysClr val="windowText" lastClr="000000"/>
-                </a:solidFill>
-              </a:rPr>
-              <a:t>(stream A: Public events)</a:t>
-            </a:r>
-          </a:p>
-        </p:txBody>
-      </p:sp>
-      <p:cxnSp>
-        <p:nvCxnSpPr>
-          <p:cNvPr id="7" name="Straight Arrow Connector 6">
-            <a:extLst>
-              <a:ext uri="{FF2B5EF4-FFF2-40B4-BE49-F238E27FC236}">
-                <a16:creationId xmlns:a16="http://schemas.microsoft.com/office/drawing/2014/main" id="{D6A85E1B-C719-CEE8-E438-61CFE3B56FA0}"/>
-              </a:ext>
-            </a:extLst>
-          </p:cNvPr>
-          <p:cNvCxnSpPr>
-            <a:cxnSpLocks/>
-          </p:cNvCxnSpPr>
-          <p:nvPr/>
-        </p:nvCxnSpPr>
-        <p:spPr>
-          <a:xfrm flipV="1">
-            <a:off x="6506631" y="4033179"/>
-            <a:ext cx="0" cy="166179"/>
-          </a:xfrm>
-          <a:prstGeom prst="straightConnector1">
-            <a:avLst/>
-          </a:prstGeom>
-          <a:ln>
-            <a:solidFill>
-              <a:srgbClr val="00B0F0"/>
-            </a:solidFill>
-            <a:tailEnd type="triangle"/>
-          </a:ln>
-        </p:spPr>
-        <p:style>
-          <a:lnRef idx="2">
-            <a:schemeClr val="accent1"/>
-          </a:lnRef>
-          <a:fillRef idx="0">
-            <a:schemeClr val="accent1"/>
-          </a:fillRef>
-          <a:effectRef idx="1">
-            <a:schemeClr val="accent1"/>
-          </a:effectRef>
-          <a:fontRef idx="minor">
-            <a:schemeClr val="tx1"/>
-          </a:fontRef>
-        </p:style>
-      </p:cxnSp>
-      <p:sp>
-        <p:nvSpPr>
-          <p:cNvPr id="8" name="Can 7">
-            <a:extLst>
-              <a:ext uri="{FF2B5EF4-FFF2-40B4-BE49-F238E27FC236}">
-                <a16:creationId xmlns:a16="http://schemas.microsoft.com/office/drawing/2014/main" id="{7DCA5B80-FEB9-E281-EC39-AE5A1D1A0D5D}"/>
-              </a:ext>
-            </a:extLst>
-          </p:cNvPr>
-          <p:cNvSpPr/>
-          <p:nvPr/>
-        </p:nvSpPr>
-        <p:spPr>
-          <a:xfrm>
-            <a:off x="1490130" y="3399107"/>
-            <a:ext cx="2116667" cy="686456"/>
-          </a:xfrm>
-          <a:prstGeom prst="can">
-            <a:avLst/>
-          </a:prstGeom>
-          <a:noFill/>
-          <a:ln>
-            <a:solidFill>
-              <a:srgbClr val="00B0F0"/>
-            </a:solidFill>
-          </a:ln>
-        </p:spPr>
-        <p:style>
-          <a:lnRef idx="2">
-            <a:schemeClr val="accent1">
-              <a:shade val="15000"/>
-            </a:schemeClr>
-          </a:lnRef>
-          <a:fillRef idx="1">
-            <a:schemeClr val="accent1"/>
-          </a:fillRef>
-          <a:effectRef idx="0">
-            <a:schemeClr val="accent1"/>
-          </a:effectRef>
-          <a:fontRef idx="minor">
-            <a:schemeClr val="lt1"/>
-          </a:fontRef>
-        </p:style>
-        <p:txBody>
-          <a:bodyPr rtlCol="0" anchor="ctr"/>
-          <a:lstStyle/>
-          <a:p>
-            <a:pPr algn="ctr"/>
-            <a:r>
-              <a:rPr lang="en-GB" dirty="0">
-                <a:solidFill>
-                  <a:sysClr val="windowText" lastClr="000000"/>
-                </a:solidFill>
-              </a:rPr>
-              <a:t>Primary Database</a:t>
-            </a:r>
-          </a:p>
-        </p:txBody>
-      </p:sp>
-      <p:cxnSp>
-        <p:nvCxnSpPr>
-          <p:cNvPr id="9" name="Straight Arrow Connector 8">
-            <a:extLst>
-              <a:ext uri="{FF2B5EF4-FFF2-40B4-BE49-F238E27FC236}">
-                <a16:creationId xmlns:a16="http://schemas.microsoft.com/office/drawing/2014/main" id="{2BE20D0A-81D1-ACC2-3FB4-3139B44E60FB}"/>
-              </a:ext>
-            </a:extLst>
-          </p:cNvPr>
-          <p:cNvCxnSpPr>
-            <a:cxnSpLocks/>
-          </p:cNvCxnSpPr>
-          <p:nvPr/>
-        </p:nvCxnSpPr>
-        <p:spPr>
-          <a:xfrm>
-            <a:off x="3759456" y="3848513"/>
-            <a:ext cx="705298" cy="0"/>
-          </a:xfrm>
-          <a:prstGeom prst="straightConnector1">
-            <a:avLst/>
-          </a:prstGeom>
-          <a:ln>
-            <a:solidFill>
-              <a:srgbClr val="00B0F0"/>
-            </a:solidFill>
-            <a:tailEnd type="triangle"/>
-          </a:ln>
-        </p:spPr>
-        <p:style>
-          <a:lnRef idx="2">
-            <a:schemeClr val="accent1"/>
-          </a:lnRef>
-          <a:fillRef idx="0">
-            <a:schemeClr val="accent1"/>
-          </a:fillRef>
-          <a:effectRef idx="1">
-            <a:schemeClr val="accent1"/>
-          </a:effectRef>
-          <a:fontRef idx="minor">
-            <a:schemeClr val="tx1"/>
-          </a:fontRef>
-        </p:style>
-      </p:cxnSp>
-      <p:sp>
-        <p:nvSpPr>
-          <p:cNvPr id="10" name="TextBox 9">
-            <a:extLst>
-              <a:ext uri="{FF2B5EF4-FFF2-40B4-BE49-F238E27FC236}">
-                <a16:creationId xmlns:a16="http://schemas.microsoft.com/office/drawing/2014/main" id="{2AF53EEE-CBAC-C9BB-5ABA-47117B070357}"/>
-              </a:ext>
-            </a:extLst>
-          </p:cNvPr>
-          <p:cNvSpPr txBox="1"/>
-          <p:nvPr/>
-        </p:nvSpPr>
-        <p:spPr>
-          <a:xfrm>
-            <a:off x="815622" y="4199358"/>
-            <a:ext cx="3059288" cy="1200329"/>
-          </a:xfrm>
-          <a:prstGeom prst="rect">
-            <a:avLst/>
-          </a:prstGeom>
-          <a:noFill/>
-        </p:spPr>
-        <p:txBody>
-          <a:bodyPr wrap="square" rtlCol="0">
-            <a:spAutoFit/>
-          </a:bodyPr>
-          <a:lstStyle/>
-          <a:p>
-            <a:pPr marL="285750" indent="-285750">
-              <a:buFont typeface="Arial" panose="020B0604020202020204" pitchFamily="34" charset="0"/>
-              <a:buChar char="•"/>
-            </a:pPr>
-            <a:r>
-              <a:rPr lang="en-GB" dirty="0"/>
-              <a:t>Node-specific database (Doesn’t need to be a DB, can be node-specific implementation)</a:t>
-            </a:r>
-          </a:p>
-        </p:txBody>
-      </p:sp>
-      <p:sp>
-        <p:nvSpPr>
-          <p:cNvPr id="11" name="Rounded Rectangle 10">
-            <a:extLst>
-              <a:ext uri="{FF2B5EF4-FFF2-40B4-BE49-F238E27FC236}">
-                <a16:creationId xmlns:a16="http://schemas.microsoft.com/office/drawing/2014/main" id="{7B16F9FB-E7F9-866D-867C-75FBBA15DC95}"/>
-              </a:ext>
-            </a:extLst>
-          </p:cNvPr>
-          <p:cNvSpPr/>
-          <p:nvPr/>
-        </p:nvSpPr>
-        <p:spPr>
-          <a:xfrm>
-            <a:off x="1829056" y="2003338"/>
-            <a:ext cx="3860799" cy="609113"/>
-          </a:xfrm>
-          <a:prstGeom prst="roundRect">
-            <a:avLst/>
-          </a:prstGeom>
-          <a:noFill/>
-          <a:ln>
-            <a:solidFill>
-              <a:srgbClr val="00B0F0"/>
-            </a:solidFill>
-          </a:ln>
-        </p:spPr>
-        <p:style>
-          <a:lnRef idx="2">
-            <a:schemeClr val="accent1">
-              <a:shade val="15000"/>
-            </a:schemeClr>
-          </a:lnRef>
-          <a:fillRef idx="1">
-            <a:schemeClr val="accent1"/>
-          </a:fillRef>
-          <a:effectRef idx="0">
-            <a:schemeClr val="accent1"/>
-          </a:effectRef>
-          <a:fontRef idx="minor">
-            <a:schemeClr val="lt1"/>
-          </a:fontRef>
-        </p:style>
-        <p:txBody>
-          <a:bodyPr rtlCol="0" anchor="ctr"/>
-          <a:lstStyle/>
-          <a:p>
-            <a:pPr algn="ctr"/>
-            <a:r>
-              <a:rPr lang="en-GB" dirty="0">
-                <a:solidFill>
-                  <a:sysClr val="windowText" lastClr="000000"/>
-                </a:solidFill>
-              </a:rPr>
-              <a:t>ESL:B – Citation Service (No Ingress)</a:t>
-            </a:r>
-          </a:p>
-          <a:p>
-            <a:pPr algn="ctr"/>
-            <a:r>
-              <a:rPr lang="en-GB" i="1" dirty="0">
-                <a:solidFill>
-                  <a:sysClr val="windowText" lastClr="000000"/>
-                </a:solidFill>
-              </a:rPr>
-              <a:t>(stream B: Citation SVC only)</a:t>
-            </a:r>
-          </a:p>
-        </p:txBody>
-      </p:sp>
-      <p:cxnSp>
-        <p:nvCxnSpPr>
-          <p:cNvPr id="12" name="Straight Arrow Connector 11">
-            <a:extLst>
-              <a:ext uri="{FF2B5EF4-FFF2-40B4-BE49-F238E27FC236}">
-                <a16:creationId xmlns:a16="http://schemas.microsoft.com/office/drawing/2014/main" id="{385405A3-10B4-63D4-13B3-D88937909C85}"/>
-              </a:ext>
-            </a:extLst>
-          </p:cNvPr>
-          <p:cNvCxnSpPr>
-            <a:cxnSpLocks/>
-          </p:cNvCxnSpPr>
-          <p:nvPr/>
-        </p:nvCxnSpPr>
-        <p:spPr>
-          <a:xfrm flipH="1" flipV="1">
-            <a:off x="3825525" y="2695397"/>
-            <a:ext cx="745063" cy="807197"/>
-          </a:xfrm>
-          <a:prstGeom prst="straightConnector1">
-            <a:avLst/>
-          </a:prstGeom>
-          <a:ln>
-            <a:solidFill>
-              <a:srgbClr val="00B0F0"/>
-            </a:solidFill>
-            <a:tailEnd type="triangle"/>
-          </a:ln>
-        </p:spPr>
-        <p:style>
-          <a:lnRef idx="2">
-            <a:schemeClr val="accent1"/>
-          </a:lnRef>
-          <a:fillRef idx="0">
-            <a:schemeClr val="accent1"/>
-          </a:fillRef>
-          <a:effectRef idx="1">
-            <a:schemeClr val="accent1"/>
-          </a:effectRef>
-          <a:fontRef idx="minor">
-            <a:schemeClr val="tx1"/>
-          </a:fontRef>
-        </p:style>
-      </p:cxnSp>
-      <p:cxnSp>
-        <p:nvCxnSpPr>
-          <p:cNvPr id="13" name="Straight Arrow Connector 12">
-            <a:extLst>
-              <a:ext uri="{FF2B5EF4-FFF2-40B4-BE49-F238E27FC236}">
-                <a16:creationId xmlns:a16="http://schemas.microsoft.com/office/drawing/2014/main" id="{5371DC70-A46A-5AEC-8E81-991EFEA923F2}"/>
-              </a:ext>
-            </a:extLst>
-          </p:cNvPr>
-          <p:cNvCxnSpPr>
-            <a:cxnSpLocks/>
-          </p:cNvCxnSpPr>
-          <p:nvPr/>
-        </p:nvCxnSpPr>
-        <p:spPr>
-          <a:xfrm flipH="1">
-            <a:off x="2774762" y="2732020"/>
-            <a:ext cx="803815" cy="597199"/>
-          </a:xfrm>
-          <a:prstGeom prst="straightConnector1">
-            <a:avLst/>
-          </a:prstGeom>
-          <a:ln>
-            <a:solidFill>
-              <a:srgbClr val="00B0F0"/>
-            </a:solidFill>
-            <a:tailEnd type="triangle"/>
-          </a:ln>
-        </p:spPr>
-        <p:style>
-          <a:lnRef idx="2">
-            <a:schemeClr val="accent1"/>
-          </a:lnRef>
-          <a:fillRef idx="0">
-            <a:schemeClr val="accent1"/>
-          </a:fillRef>
-          <a:effectRef idx="1">
-            <a:schemeClr val="accent1"/>
-          </a:effectRef>
-          <a:fontRef idx="minor">
-            <a:schemeClr val="tx1"/>
-          </a:fontRef>
-        </p:style>
-      </p:cxnSp>
-      <p:sp>
-        <p:nvSpPr>
-          <p:cNvPr id="14" name="TextBox 13">
-            <a:extLst>
-              <a:ext uri="{FF2B5EF4-FFF2-40B4-BE49-F238E27FC236}">
-                <a16:creationId xmlns:a16="http://schemas.microsoft.com/office/drawing/2014/main" id="{7A1A21B0-D61A-98AE-E1DB-93CD877865C9}"/>
-              </a:ext>
-            </a:extLst>
-          </p:cNvPr>
-          <p:cNvSpPr txBox="1"/>
-          <p:nvPr/>
-        </p:nvSpPr>
-        <p:spPr>
-          <a:xfrm>
-            <a:off x="9008533" y="1106311"/>
-            <a:ext cx="2888288" cy="2862322"/>
-          </a:xfrm>
-          <a:prstGeom prst="rect">
-            <a:avLst/>
-          </a:prstGeom>
-          <a:noFill/>
-        </p:spPr>
-        <p:txBody>
-          <a:bodyPr wrap="square" rtlCol="0">
-            <a:spAutoFit/>
-          </a:bodyPr>
-          <a:lstStyle/>
-          <a:p>
-            <a:pPr marL="285750" indent="-285750">
-              <a:buFont typeface="Arial" panose="020B0604020202020204" pitchFamily="34" charset="0"/>
-              <a:buChar char="•"/>
-            </a:pPr>
-            <a:r>
-              <a:rPr lang="en-GB" dirty="0"/>
-              <a:t>Write events now send messages to Stream B, picked up by Event Listener B which actually writes to the database.</a:t>
-            </a:r>
-          </a:p>
-          <a:p>
-            <a:pPr marL="285750" indent="-285750">
-              <a:buFont typeface="Arial" panose="020B0604020202020204" pitchFamily="34" charset="0"/>
-              <a:buChar char="•"/>
-            </a:pPr>
-            <a:r>
-              <a:rPr lang="en-GB" dirty="0"/>
-              <a:t>Event Listener A is for new citation entries, Event Listener B is for private database writes.</a:t>
-            </a:r>
-          </a:p>
-        </p:txBody>
-      </p:sp>
-    </p:spTree>
-    <p:extLst>
-      <p:ext uri="{BB962C8B-B14F-4D97-AF65-F5344CB8AC3E}">
-        <p14:creationId xmlns:p14="http://schemas.microsoft.com/office/powerpoint/2010/main" val="4026127305"/>
-      </p:ext>
-    </p:extLst>
-  </p:cSld>
-  <p:clrMapOvr>
-    <a:masterClrMapping/>
-  </p:clrMapOvr>
-</p:sld>
-</file>
-
-<file path=ppt/slides/slide5.xml><?xml version="1.0" encoding="utf-8"?>
-<p:sld xmlns:a="http://schemas.openxmlformats.org/drawingml/2006/main" xmlns:r="http://schemas.openxmlformats.org/officeDocument/2006/relationships" xmlns:p="http://schemas.openxmlformats.org/presentationml/2006/main">
-  <p:cSld>
-    <p:spTree>
-      <p:nvGrpSpPr>
-        <p:cNvPr id="1" name=""/>
-        <p:cNvGrpSpPr/>
-        <p:nvPr/>
-      </p:nvGrpSpPr>
-      <p:grpSpPr>
-        <a:xfrm>
-          <a:off x="0" y="0"/>
-          <a:ext cx="0" cy="0"/>
-          <a:chOff x="0" y="0"/>
-          <a:chExt cx="0" cy="0"/>
-        </a:xfrm>
-      </p:grpSpPr>
-      <p:sp>
-        <p:nvSpPr>
-          <p:cNvPr id="2" name="Title 1">
-            <a:extLst>
-              <a:ext uri="{FF2B5EF4-FFF2-40B4-BE49-F238E27FC236}">
-                <a16:creationId xmlns:a16="http://schemas.microsoft.com/office/drawing/2014/main" id="{2D89825C-D437-6119-3DF0-EB8E1C9A3394}"/>
-              </a:ext>
-            </a:extLst>
-          </p:cNvPr>
-          <p:cNvSpPr>
-            <a:spLocks noGrp="1"/>
-          </p:cNvSpPr>
-          <p:nvPr>
-            <p:ph type="title"/>
-          </p:nvPr>
-        </p:nvSpPr>
-        <p:spPr/>
-        <p:txBody>
-          <a:bodyPr/>
-          <a:lstStyle/>
-          <a:p>
-            <a:r>
-              <a:rPr lang="en-GB" dirty="0"/>
-              <a:t>Event Stream B Message Options</a:t>
-            </a:r>
-          </a:p>
-        </p:txBody>
-      </p:sp>
-      <p:sp>
-        <p:nvSpPr>
-          <p:cNvPr id="3" name="Content Placeholder 2">
-            <a:extLst>
-              <a:ext uri="{FF2B5EF4-FFF2-40B4-BE49-F238E27FC236}">
-                <a16:creationId xmlns:a16="http://schemas.microsoft.com/office/drawing/2014/main" id="{0E5ECC73-A1DE-B4AC-D367-375BC9F19392}"/>
-              </a:ext>
-            </a:extLst>
-          </p:cNvPr>
-          <p:cNvSpPr>
-            <a:spLocks noGrp="1"/>
-          </p:cNvSpPr>
-          <p:nvPr>
-            <p:ph idx="1"/>
-          </p:nvPr>
-        </p:nvSpPr>
-        <p:spPr>
-          <a:xfrm>
-            <a:off x="838200" y="1825625"/>
-            <a:ext cx="10515600" cy="2334592"/>
-          </a:xfrm>
-        </p:spPr>
-        <p:txBody>
-          <a:bodyPr>
-            <a:normAutofit/>
-          </a:bodyPr>
-          <a:lstStyle/>
-          <a:p>
-            <a:r>
-              <a:rPr lang="en-GB" sz="2000" dirty="0"/>
-              <a:t>Table: </a:t>
-            </a:r>
-            <a:r>
-              <a:rPr lang="en-GB" sz="2000" dirty="0" err="1"/>
-              <a:t>Table_Name</a:t>
-            </a:r>
-            <a:endParaRPr lang="en-GB" sz="2000" dirty="0"/>
-          </a:p>
-          <a:p>
-            <a:r>
-              <a:rPr lang="en-GB" sz="2000" dirty="0"/>
-              <a:t>Create: {Validated Model Content}</a:t>
-            </a:r>
-          </a:p>
-          <a:p>
-            <a:r>
-              <a:rPr lang="en-GB" sz="2000" dirty="0"/>
-              <a:t>Delete: {Model PK} (Non-Cascading)</a:t>
-            </a:r>
-          </a:p>
-          <a:p>
-            <a:endParaRPr lang="en-GB" sz="2000" dirty="0"/>
-          </a:p>
-          <a:p>
-            <a:r>
-              <a:rPr lang="en-GB" sz="2000" dirty="0"/>
-              <a:t>Rules applied to each model content field in-line with existing Django DB setup, to be agreed by Citation panel members</a:t>
-            </a:r>
-          </a:p>
-        </p:txBody>
-      </p:sp>
-    </p:spTree>
-    <p:extLst>
-      <p:ext uri="{BB962C8B-B14F-4D97-AF65-F5344CB8AC3E}">
-        <p14:creationId xmlns:p14="http://schemas.microsoft.com/office/powerpoint/2010/main" val="824007482"/>
       </p:ext>
     </p:extLst>
   </p:cSld>

</xml_diff>